<commit_message>
Finish project: Replace diagram with real SSMS screenshot and update documentation
- Replaced schematic database diagram with real SSMS diagram showing all 10 23_09 tables
- Updated figure 25 in explanatory note with proper diagram
- Updated slide 5 in presentation with real diagram
- Generated PDF version of explanatory note
- Saved final diagram as PNG in shots/ directory

All passwords removed from tracked files; connection settings in App.config.local (not tracked)
</commit_message>
<xml_diff>
--- a/Презентация к защите.pptx
+++ b/Презентация к защите.pptx
@@ -137,7 +137,7 @@
           <p:cNvPr id="2" name="Заголовок 1">
             <a:extLst>
               <a:ext uri="{FF2B5EF4-FFF2-40B4-BE49-F238E27FC236}">
-                <a16:creationId xmlns:a16="http://schemas.microsoft.com/office/drawing/2014/main" id="{83BE7325-DDAB-DE65-874B-03EF5DC46C4F}"/>
+                <a16:creationId xmlns:a16="http://schemas.microsoft.com/office/drawing/2014/main" id="{EE94B20A-B01F-21FA-E836-7D6BB49EA453}"/>
               </a:ext>
             </a:extLst>
           </p:cNvPr>
@@ -174,7 +174,7 @@
           <p:cNvPr id="3" name="Подзаголовок 2">
             <a:extLst>
               <a:ext uri="{FF2B5EF4-FFF2-40B4-BE49-F238E27FC236}">
-                <a16:creationId xmlns:a16="http://schemas.microsoft.com/office/drawing/2014/main" id="{8147867F-3AA7-1589-26C4-246B79F72A07}"/>
+                <a16:creationId xmlns:a16="http://schemas.microsoft.com/office/drawing/2014/main" id="{4578432F-DB23-4B23-719D-54E46714234E}"/>
               </a:ext>
             </a:extLst>
           </p:cNvPr>
@@ -244,7 +244,7 @@
           <p:cNvPr id="4" name="Дата 3">
             <a:extLst>
               <a:ext uri="{FF2B5EF4-FFF2-40B4-BE49-F238E27FC236}">
-                <a16:creationId xmlns:a16="http://schemas.microsoft.com/office/drawing/2014/main" id="{701ECDA0-09C1-C317-89CB-081EA3E8EC0A}"/>
+                <a16:creationId xmlns:a16="http://schemas.microsoft.com/office/drawing/2014/main" id="{947C741E-FEDF-EBD2-854F-FCE642255DB5}"/>
               </a:ext>
             </a:extLst>
           </p:cNvPr>
@@ -260,9 +260,9 @@
           <a:bodyPr/>
           <a:lstStyle/>
           <a:p>
-            <a:fld id="{44447AD5-A860-4F74-86B1-0034733D12B0}" type="datetimeFigureOut">
+            <a:fld id="{FECAD547-0098-4F95-A3E6-B35FDCDAFEB6}" type="datetimeFigureOut">
               <a:rPr lang="ru-RU" smtClean="0"/>
-              <a:t>21.10.2026</a:t>
+              <a:t>22.10.2026</a:t>
             </a:fld>
             <a:endParaRPr lang="ru-RU"/>
           </a:p>
@@ -273,7 +273,7 @@
           <p:cNvPr id="5" name="Нижний колонтитул 4">
             <a:extLst>
               <a:ext uri="{FF2B5EF4-FFF2-40B4-BE49-F238E27FC236}">
-                <a16:creationId xmlns:a16="http://schemas.microsoft.com/office/drawing/2014/main" id="{C60B8203-7EFE-8215-5141-12B284AC9AB9}"/>
+                <a16:creationId xmlns:a16="http://schemas.microsoft.com/office/drawing/2014/main" id="{AF337277-ED54-A559-296C-2FFA8A5AF8A5}"/>
               </a:ext>
             </a:extLst>
           </p:cNvPr>
@@ -298,7 +298,7 @@
           <p:cNvPr id="6" name="Номер слайда 5">
             <a:extLst>
               <a:ext uri="{FF2B5EF4-FFF2-40B4-BE49-F238E27FC236}">
-                <a16:creationId xmlns:a16="http://schemas.microsoft.com/office/drawing/2014/main" id="{A557A8E2-E821-B079-EDD6-3BBBD6189BD0}"/>
+                <a16:creationId xmlns:a16="http://schemas.microsoft.com/office/drawing/2014/main" id="{FFA792D4-1D6E-BD80-D41E-CE700217E6DE}"/>
               </a:ext>
             </a:extLst>
           </p:cNvPr>
@@ -314,7 +314,7 @@
           <a:bodyPr/>
           <a:lstStyle/>
           <a:p>
-            <a:fld id="{D99F9743-DED8-4E9C-BD89-EA992B299253}" type="slidenum">
+            <a:fld id="{14248956-2374-48B4-B20B-A1021DAEFE0D}" type="slidenum">
               <a:rPr lang="ru-RU" smtClean="0"/>
               <a:t>‹#›</a:t>
             </a:fld>
@@ -325,7 +325,7 @@
     </p:spTree>
     <p:extLst>
       <p:ext uri="{BB962C8B-B14F-4D97-AF65-F5344CB8AC3E}">
-        <p14:creationId xmlns:p14="http://schemas.microsoft.com/office/powerpoint/2010/main" val="3565682924"/>
+        <p14:creationId xmlns:p14="http://schemas.microsoft.com/office/powerpoint/2010/main" val="1701829731"/>
       </p:ext>
     </p:extLst>
   </p:cSld>
@@ -357,7 +357,7 @@
           <p:cNvPr id="2" name="Заголовок 1">
             <a:extLst>
               <a:ext uri="{FF2B5EF4-FFF2-40B4-BE49-F238E27FC236}">
-                <a16:creationId xmlns:a16="http://schemas.microsoft.com/office/drawing/2014/main" id="{DB800919-BEDF-80C1-ABBD-49049895A560}"/>
+                <a16:creationId xmlns:a16="http://schemas.microsoft.com/office/drawing/2014/main" id="{2EE9AF7F-CDE3-E01A-70F3-33BAD59B0F9C}"/>
               </a:ext>
             </a:extLst>
           </p:cNvPr>
@@ -385,7 +385,7 @@
           <p:cNvPr id="3" name="Вертикальный текст 2">
             <a:extLst>
               <a:ext uri="{FF2B5EF4-FFF2-40B4-BE49-F238E27FC236}">
-                <a16:creationId xmlns:a16="http://schemas.microsoft.com/office/drawing/2014/main" id="{800219FD-FEF2-C24F-0D25-4A7A0519C91C}"/>
+                <a16:creationId xmlns:a16="http://schemas.microsoft.com/office/drawing/2014/main" id="{D7EA22BC-7755-9735-3C1C-1847B3A8C3E6}"/>
               </a:ext>
             </a:extLst>
           </p:cNvPr>
@@ -442,7 +442,7 @@
           <p:cNvPr id="4" name="Дата 3">
             <a:extLst>
               <a:ext uri="{FF2B5EF4-FFF2-40B4-BE49-F238E27FC236}">
-                <a16:creationId xmlns:a16="http://schemas.microsoft.com/office/drawing/2014/main" id="{14D6CA79-6D3A-1FE2-30A0-EEC3236C1E0D}"/>
+                <a16:creationId xmlns:a16="http://schemas.microsoft.com/office/drawing/2014/main" id="{EB03F557-D6B8-B4CA-D5B3-A40779BFAE91}"/>
               </a:ext>
             </a:extLst>
           </p:cNvPr>
@@ -458,9 +458,9 @@
           <a:bodyPr/>
           <a:lstStyle/>
           <a:p>
-            <a:fld id="{44447AD5-A860-4F74-86B1-0034733D12B0}" type="datetimeFigureOut">
+            <a:fld id="{FECAD547-0098-4F95-A3E6-B35FDCDAFEB6}" type="datetimeFigureOut">
               <a:rPr lang="ru-RU" smtClean="0"/>
-              <a:t>21.10.2026</a:t>
+              <a:t>22.10.2026</a:t>
             </a:fld>
             <a:endParaRPr lang="ru-RU"/>
           </a:p>
@@ -471,7 +471,7 @@
           <p:cNvPr id="5" name="Нижний колонтитул 4">
             <a:extLst>
               <a:ext uri="{FF2B5EF4-FFF2-40B4-BE49-F238E27FC236}">
-                <a16:creationId xmlns:a16="http://schemas.microsoft.com/office/drawing/2014/main" id="{AD8D9B5D-3577-C09D-C606-C4EEEE446877}"/>
+                <a16:creationId xmlns:a16="http://schemas.microsoft.com/office/drawing/2014/main" id="{5F1D34D3-F6F8-A691-4E6C-62519F96B251}"/>
               </a:ext>
             </a:extLst>
           </p:cNvPr>
@@ -496,7 +496,7 @@
           <p:cNvPr id="6" name="Номер слайда 5">
             <a:extLst>
               <a:ext uri="{FF2B5EF4-FFF2-40B4-BE49-F238E27FC236}">
-                <a16:creationId xmlns:a16="http://schemas.microsoft.com/office/drawing/2014/main" id="{70E230C2-A15D-AAD6-1C2D-39E12F013282}"/>
+                <a16:creationId xmlns:a16="http://schemas.microsoft.com/office/drawing/2014/main" id="{240DE742-0379-3B64-0771-C8D4F32EB16E}"/>
               </a:ext>
             </a:extLst>
           </p:cNvPr>
@@ -512,7 +512,7 @@
           <a:bodyPr/>
           <a:lstStyle/>
           <a:p>
-            <a:fld id="{D99F9743-DED8-4E9C-BD89-EA992B299253}" type="slidenum">
+            <a:fld id="{14248956-2374-48B4-B20B-A1021DAEFE0D}" type="slidenum">
               <a:rPr lang="ru-RU" smtClean="0"/>
               <a:t>‹#›</a:t>
             </a:fld>
@@ -523,7 +523,7 @@
     </p:spTree>
     <p:extLst>
       <p:ext uri="{BB962C8B-B14F-4D97-AF65-F5344CB8AC3E}">
-        <p14:creationId xmlns:p14="http://schemas.microsoft.com/office/powerpoint/2010/main" val="501709549"/>
+        <p14:creationId xmlns:p14="http://schemas.microsoft.com/office/powerpoint/2010/main" val="1908382336"/>
       </p:ext>
     </p:extLst>
   </p:cSld>
@@ -555,7 +555,7 @@
           <p:cNvPr id="2" name="Вертикальный заголовок 1">
             <a:extLst>
               <a:ext uri="{FF2B5EF4-FFF2-40B4-BE49-F238E27FC236}">
-                <a16:creationId xmlns:a16="http://schemas.microsoft.com/office/drawing/2014/main" id="{5A477D64-7C5F-C557-DB67-932354D34264}"/>
+                <a16:creationId xmlns:a16="http://schemas.microsoft.com/office/drawing/2014/main" id="{570455D2-9415-313D-B5A1-729324D5CDC0}"/>
               </a:ext>
             </a:extLst>
           </p:cNvPr>
@@ -588,7 +588,7 @@
           <p:cNvPr id="3" name="Вертикальный текст 2">
             <a:extLst>
               <a:ext uri="{FF2B5EF4-FFF2-40B4-BE49-F238E27FC236}">
-                <a16:creationId xmlns:a16="http://schemas.microsoft.com/office/drawing/2014/main" id="{69D9405D-00E7-195C-6B2A-9C16B93624AD}"/>
+                <a16:creationId xmlns:a16="http://schemas.microsoft.com/office/drawing/2014/main" id="{A60FB949-6E09-56BD-86B9-21A39907DB02}"/>
               </a:ext>
             </a:extLst>
           </p:cNvPr>
@@ -650,7 +650,7 @@
           <p:cNvPr id="4" name="Дата 3">
             <a:extLst>
               <a:ext uri="{FF2B5EF4-FFF2-40B4-BE49-F238E27FC236}">
-                <a16:creationId xmlns:a16="http://schemas.microsoft.com/office/drawing/2014/main" id="{74CCD867-E66C-8A06-BB9A-5A0EB04586E6}"/>
+                <a16:creationId xmlns:a16="http://schemas.microsoft.com/office/drawing/2014/main" id="{3D34B6E7-54AD-2DBA-E641-F6EE7A7285C0}"/>
               </a:ext>
             </a:extLst>
           </p:cNvPr>
@@ -666,9 +666,9 @@
           <a:bodyPr/>
           <a:lstStyle/>
           <a:p>
-            <a:fld id="{44447AD5-A860-4F74-86B1-0034733D12B0}" type="datetimeFigureOut">
+            <a:fld id="{FECAD547-0098-4F95-A3E6-B35FDCDAFEB6}" type="datetimeFigureOut">
               <a:rPr lang="ru-RU" smtClean="0"/>
-              <a:t>21.10.2026</a:t>
+              <a:t>22.10.2026</a:t>
             </a:fld>
             <a:endParaRPr lang="ru-RU"/>
           </a:p>
@@ -679,7 +679,7 @@
           <p:cNvPr id="5" name="Нижний колонтитул 4">
             <a:extLst>
               <a:ext uri="{FF2B5EF4-FFF2-40B4-BE49-F238E27FC236}">
-                <a16:creationId xmlns:a16="http://schemas.microsoft.com/office/drawing/2014/main" id="{C0032D20-E4A5-0C3C-B1BA-345B5B219E8A}"/>
+                <a16:creationId xmlns:a16="http://schemas.microsoft.com/office/drawing/2014/main" id="{3D5E8A28-3292-AA4A-A9FF-FD41BB7FD919}"/>
               </a:ext>
             </a:extLst>
           </p:cNvPr>
@@ -704,7 +704,7 @@
           <p:cNvPr id="6" name="Номер слайда 5">
             <a:extLst>
               <a:ext uri="{FF2B5EF4-FFF2-40B4-BE49-F238E27FC236}">
-                <a16:creationId xmlns:a16="http://schemas.microsoft.com/office/drawing/2014/main" id="{F0D54CD9-9C20-E737-AA83-0C1E9912F3E8}"/>
+                <a16:creationId xmlns:a16="http://schemas.microsoft.com/office/drawing/2014/main" id="{BBB35B90-9B41-D63E-4361-A2141E343F50}"/>
               </a:ext>
             </a:extLst>
           </p:cNvPr>
@@ -720,7 +720,7 @@
           <a:bodyPr/>
           <a:lstStyle/>
           <a:p>
-            <a:fld id="{D99F9743-DED8-4E9C-BD89-EA992B299253}" type="slidenum">
+            <a:fld id="{14248956-2374-48B4-B20B-A1021DAEFE0D}" type="slidenum">
               <a:rPr lang="ru-RU" smtClean="0"/>
               <a:t>‹#›</a:t>
             </a:fld>
@@ -731,7 +731,7 @@
     </p:spTree>
     <p:extLst>
       <p:ext uri="{BB962C8B-B14F-4D97-AF65-F5344CB8AC3E}">
-        <p14:creationId xmlns:p14="http://schemas.microsoft.com/office/powerpoint/2010/main" val="543163219"/>
+        <p14:creationId xmlns:p14="http://schemas.microsoft.com/office/powerpoint/2010/main" val="1147969438"/>
       </p:ext>
     </p:extLst>
   </p:cSld>
@@ -763,7 +763,7 @@
           <p:cNvPr id="2" name="Заголовок 1">
             <a:extLst>
               <a:ext uri="{FF2B5EF4-FFF2-40B4-BE49-F238E27FC236}">
-                <a16:creationId xmlns:a16="http://schemas.microsoft.com/office/drawing/2014/main" id="{A6F3B003-38AB-616E-C820-F363AA65A7BB}"/>
+                <a16:creationId xmlns:a16="http://schemas.microsoft.com/office/drawing/2014/main" id="{262D4BFD-C2DC-275B-4294-D81A3522467D}"/>
               </a:ext>
             </a:extLst>
           </p:cNvPr>
@@ -791,7 +791,7 @@
           <p:cNvPr id="3" name="Объект 2">
             <a:extLst>
               <a:ext uri="{FF2B5EF4-FFF2-40B4-BE49-F238E27FC236}">
-                <a16:creationId xmlns:a16="http://schemas.microsoft.com/office/drawing/2014/main" id="{94771D02-9A8F-44F5-F514-2294B4AB114D}"/>
+                <a16:creationId xmlns:a16="http://schemas.microsoft.com/office/drawing/2014/main" id="{E8D04246-4F6C-0F05-221A-567A323BF6F5}"/>
               </a:ext>
             </a:extLst>
           </p:cNvPr>
@@ -848,7 +848,7 @@
           <p:cNvPr id="4" name="Дата 3">
             <a:extLst>
               <a:ext uri="{FF2B5EF4-FFF2-40B4-BE49-F238E27FC236}">
-                <a16:creationId xmlns:a16="http://schemas.microsoft.com/office/drawing/2014/main" id="{0E5EB716-DA22-AC92-EAB2-CC29FF5605C1}"/>
+                <a16:creationId xmlns:a16="http://schemas.microsoft.com/office/drawing/2014/main" id="{84065619-40D9-3706-DC43-82098FAACAC0}"/>
               </a:ext>
             </a:extLst>
           </p:cNvPr>
@@ -864,9 +864,9 @@
           <a:bodyPr/>
           <a:lstStyle/>
           <a:p>
-            <a:fld id="{44447AD5-A860-4F74-86B1-0034733D12B0}" type="datetimeFigureOut">
+            <a:fld id="{FECAD547-0098-4F95-A3E6-B35FDCDAFEB6}" type="datetimeFigureOut">
               <a:rPr lang="ru-RU" smtClean="0"/>
-              <a:t>21.10.2026</a:t>
+              <a:t>22.10.2026</a:t>
             </a:fld>
             <a:endParaRPr lang="ru-RU"/>
           </a:p>
@@ -877,7 +877,7 @@
           <p:cNvPr id="5" name="Нижний колонтитул 4">
             <a:extLst>
               <a:ext uri="{FF2B5EF4-FFF2-40B4-BE49-F238E27FC236}">
-                <a16:creationId xmlns:a16="http://schemas.microsoft.com/office/drawing/2014/main" id="{58BEA53A-90AE-828C-2816-D5CE504600FF}"/>
+                <a16:creationId xmlns:a16="http://schemas.microsoft.com/office/drawing/2014/main" id="{40A27328-30F0-89AB-53A7-06676921D588}"/>
               </a:ext>
             </a:extLst>
           </p:cNvPr>
@@ -902,7 +902,7 @@
           <p:cNvPr id="6" name="Номер слайда 5">
             <a:extLst>
               <a:ext uri="{FF2B5EF4-FFF2-40B4-BE49-F238E27FC236}">
-                <a16:creationId xmlns:a16="http://schemas.microsoft.com/office/drawing/2014/main" id="{471D400F-1E5E-CABA-093C-0A60030875B4}"/>
+                <a16:creationId xmlns:a16="http://schemas.microsoft.com/office/drawing/2014/main" id="{2A50D9C9-3F7A-13A3-940D-2F36A68CB925}"/>
               </a:ext>
             </a:extLst>
           </p:cNvPr>
@@ -918,7 +918,7 @@
           <a:bodyPr/>
           <a:lstStyle/>
           <a:p>
-            <a:fld id="{D99F9743-DED8-4E9C-BD89-EA992B299253}" type="slidenum">
+            <a:fld id="{14248956-2374-48B4-B20B-A1021DAEFE0D}" type="slidenum">
               <a:rPr lang="ru-RU" smtClean="0"/>
               <a:t>‹#›</a:t>
             </a:fld>
@@ -929,7 +929,7 @@
     </p:spTree>
     <p:extLst>
       <p:ext uri="{BB962C8B-B14F-4D97-AF65-F5344CB8AC3E}">
-        <p14:creationId xmlns:p14="http://schemas.microsoft.com/office/powerpoint/2010/main" val="3583893704"/>
+        <p14:creationId xmlns:p14="http://schemas.microsoft.com/office/powerpoint/2010/main" val="2086041580"/>
       </p:ext>
     </p:extLst>
   </p:cSld>
@@ -961,7 +961,7 @@
           <p:cNvPr id="2" name="Заголовок 1">
             <a:extLst>
               <a:ext uri="{FF2B5EF4-FFF2-40B4-BE49-F238E27FC236}">
-                <a16:creationId xmlns:a16="http://schemas.microsoft.com/office/drawing/2014/main" id="{432AAE64-2264-0F5D-6EA9-F36EE75B2932}"/>
+                <a16:creationId xmlns:a16="http://schemas.microsoft.com/office/drawing/2014/main" id="{83EDF6B5-24D2-76A1-854B-C309BF0A2361}"/>
               </a:ext>
             </a:extLst>
           </p:cNvPr>
@@ -998,7 +998,7 @@
           <p:cNvPr id="3" name="Текст 2">
             <a:extLst>
               <a:ext uri="{FF2B5EF4-FFF2-40B4-BE49-F238E27FC236}">
-                <a16:creationId xmlns:a16="http://schemas.microsoft.com/office/drawing/2014/main" id="{9B8EEE28-936F-B786-0B92-F723AE3BCA1E}"/>
+                <a16:creationId xmlns:a16="http://schemas.microsoft.com/office/drawing/2014/main" id="{42FFB05D-6BBB-0B1D-51A9-8E74225A0CA1}"/>
               </a:ext>
             </a:extLst>
           </p:cNvPr>
@@ -1123,7 +1123,7 @@
           <p:cNvPr id="4" name="Дата 3">
             <a:extLst>
               <a:ext uri="{FF2B5EF4-FFF2-40B4-BE49-F238E27FC236}">
-                <a16:creationId xmlns:a16="http://schemas.microsoft.com/office/drawing/2014/main" id="{B649DAAA-A33F-B997-AAA0-47FC9F25B7D2}"/>
+                <a16:creationId xmlns:a16="http://schemas.microsoft.com/office/drawing/2014/main" id="{E37F1CF9-2F23-C988-9E9C-32B39923D99A}"/>
               </a:ext>
             </a:extLst>
           </p:cNvPr>
@@ -1139,9 +1139,9 @@
           <a:bodyPr/>
           <a:lstStyle/>
           <a:p>
-            <a:fld id="{44447AD5-A860-4F74-86B1-0034733D12B0}" type="datetimeFigureOut">
+            <a:fld id="{FECAD547-0098-4F95-A3E6-B35FDCDAFEB6}" type="datetimeFigureOut">
               <a:rPr lang="ru-RU" smtClean="0"/>
-              <a:t>21.10.2026</a:t>
+              <a:t>22.10.2026</a:t>
             </a:fld>
             <a:endParaRPr lang="ru-RU"/>
           </a:p>
@@ -1152,7 +1152,7 @@
           <p:cNvPr id="5" name="Нижний колонтитул 4">
             <a:extLst>
               <a:ext uri="{FF2B5EF4-FFF2-40B4-BE49-F238E27FC236}">
-                <a16:creationId xmlns:a16="http://schemas.microsoft.com/office/drawing/2014/main" id="{E41408AC-C8FC-3670-8DF7-0E0F6F2A722B}"/>
+                <a16:creationId xmlns:a16="http://schemas.microsoft.com/office/drawing/2014/main" id="{C2AFEEAF-BF07-E308-7B51-B21074B3E8A4}"/>
               </a:ext>
             </a:extLst>
           </p:cNvPr>
@@ -1177,7 +1177,7 @@
           <p:cNvPr id="6" name="Номер слайда 5">
             <a:extLst>
               <a:ext uri="{FF2B5EF4-FFF2-40B4-BE49-F238E27FC236}">
-                <a16:creationId xmlns:a16="http://schemas.microsoft.com/office/drawing/2014/main" id="{DB580292-2524-299E-917A-4FF3CDED4857}"/>
+                <a16:creationId xmlns:a16="http://schemas.microsoft.com/office/drawing/2014/main" id="{C8B75AD9-7F0E-5AAF-5C27-3FBB83B01005}"/>
               </a:ext>
             </a:extLst>
           </p:cNvPr>
@@ -1193,7 +1193,7 @@
           <a:bodyPr/>
           <a:lstStyle/>
           <a:p>
-            <a:fld id="{D99F9743-DED8-4E9C-BD89-EA992B299253}" type="slidenum">
+            <a:fld id="{14248956-2374-48B4-B20B-A1021DAEFE0D}" type="slidenum">
               <a:rPr lang="ru-RU" smtClean="0"/>
               <a:t>‹#›</a:t>
             </a:fld>
@@ -1204,7 +1204,7 @@
     </p:spTree>
     <p:extLst>
       <p:ext uri="{BB962C8B-B14F-4D97-AF65-F5344CB8AC3E}">
-        <p14:creationId xmlns:p14="http://schemas.microsoft.com/office/powerpoint/2010/main" val="1813767910"/>
+        <p14:creationId xmlns:p14="http://schemas.microsoft.com/office/powerpoint/2010/main" val="2481901385"/>
       </p:ext>
     </p:extLst>
   </p:cSld>
@@ -1236,7 +1236,7 @@
           <p:cNvPr id="2" name="Заголовок 1">
             <a:extLst>
               <a:ext uri="{FF2B5EF4-FFF2-40B4-BE49-F238E27FC236}">
-                <a16:creationId xmlns:a16="http://schemas.microsoft.com/office/drawing/2014/main" id="{694CF0A3-035A-0F2F-8D4A-3548247A3A21}"/>
+                <a16:creationId xmlns:a16="http://schemas.microsoft.com/office/drawing/2014/main" id="{85DE49E3-1C07-198B-A641-AB00A609285E}"/>
               </a:ext>
             </a:extLst>
           </p:cNvPr>
@@ -1264,7 +1264,7 @@
           <p:cNvPr id="3" name="Объект 2">
             <a:extLst>
               <a:ext uri="{FF2B5EF4-FFF2-40B4-BE49-F238E27FC236}">
-                <a16:creationId xmlns:a16="http://schemas.microsoft.com/office/drawing/2014/main" id="{FF7EA41E-1E7F-C0C3-9626-1F0188605BFA}"/>
+                <a16:creationId xmlns:a16="http://schemas.microsoft.com/office/drawing/2014/main" id="{7B8A60D2-5845-27EC-2188-58703EE0D058}"/>
               </a:ext>
             </a:extLst>
           </p:cNvPr>
@@ -1326,7 +1326,7 @@
           <p:cNvPr id="4" name="Объект 3">
             <a:extLst>
               <a:ext uri="{FF2B5EF4-FFF2-40B4-BE49-F238E27FC236}">
-                <a16:creationId xmlns:a16="http://schemas.microsoft.com/office/drawing/2014/main" id="{3350FA24-2401-95E9-C225-F7104507CEDD}"/>
+                <a16:creationId xmlns:a16="http://schemas.microsoft.com/office/drawing/2014/main" id="{0DC8DFD1-056A-F35B-1223-EBECFCADCEA9}"/>
               </a:ext>
             </a:extLst>
           </p:cNvPr>
@@ -1388,7 +1388,7 @@
           <p:cNvPr id="5" name="Дата 4">
             <a:extLst>
               <a:ext uri="{FF2B5EF4-FFF2-40B4-BE49-F238E27FC236}">
-                <a16:creationId xmlns:a16="http://schemas.microsoft.com/office/drawing/2014/main" id="{091B50D3-E316-CB2F-128F-14E54911CBDB}"/>
+                <a16:creationId xmlns:a16="http://schemas.microsoft.com/office/drawing/2014/main" id="{D4CA2D5A-4CDB-435D-B9A0-AB913AE15FCD}"/>
               </a:ext>
             </a:extLst>
           </p:cNvPr>
@@ -1404,9 +1404,9 @@
           <a:bodyPr/>
           <a:lstStyle/>
           <a:p>
-            <a:fld id="{44447AD5-A860-4F74-86B1-0034733D12B0}" type="datetimeFigureOut">
+            <a:fld id="{FECAD547-0098-4F95-A3E6-B35FDCDAFEB6}" type="datetimeFigureOut">
               <a:rPr lang="ru-RU" smtClean="0"/>
-              <a:t>21.10.2026</a:t>
+              <a:t>22.10.2026</a:t>
             </a:fld>
             <a:endParaRPr lang="ru-RU"/>
           </a:p>
@@ -1417,7 +1417,7 @@
           <p:cNvPr id="6" name="Нижний колонтитул 5">
             <a:extLst>
               <a:ext uri="{FF2B5EF4-FFF2-40B4-BE49-F238E27FC236}">
-                <a16:creationId xmlns:a16="http://schemas.microsoft.com/office/drawing/2014/main" id="{89B9D1A6-28B0-EE14-5730-FF1494C25F4C}"/>
+                <a16:creationId xmlns:a16="http://schemas.microsoft.com/office/drawing/2014/main" id="{5BCC97E0-023C-86E8-8D0E-ED20AD7B5142}"/>
               </a:ext>
             </a:extLst>
           </p:cNvPr>
@@ -1442,7 +1442,7 @@
           <p:cNvPr id="7" name="Номер слайда 6">
             <a:extLst>
               <a:ext uri="{FF2B5EF4-FFF2-40B4-BE49-F238E27FC236}">
-                <a16:creationId xmlns:a16="http://schemas.microsoft.com/office/drawing/2014/main" id="{E82BDE28-6DB7-1B04-AD0E-29FB0C302F3A}"/>
+                <a16:creationId xmlns:a16="http://schemas.microsoft.com/office/drawing/2014/main" id="{640C13D7-5D83-2213-C4B0-6EF9EED9D8F0}"/>
               </a:ext>
             </a:extLst>
           </p:cNvPr>
@@ -1458,7 +1458,7 @@
           <a:bodyPr/>
           <a:lstStyle/>
           <a:p>
-            <a:fld id="{D99F9743-DED8-4E9C-BD89-EA992B299253}" type="slidenum">
+            <a:fld id="{14248956-2374-48B4-B20B-A1021DAEFE0D}" type="slidenum">
               <a:rPr lang="ru-RU" smtClean="0"/>
               <a:t>‹#›</a:t>
             </a:fld>
@@ -1469,7 +1469,7 @@
     </p:spTree>
     <p:extLst>
       <p:ext uri="{BB962C8B-B14F-4D97-AF65-F5344CB8AC3E}">
-        <p14:creationId xmlns:p14="http://schemas.microsoft.com/office/powerpoint/2010/main" val="4137191455"/>
+        <p14:creationId xmlns:p14="http://schemas.microsoft.com/office/powerpoint/2010/main" val="3651029011"/>
       </p:ext>
     </p:extLst>
   </p:cSld>
@@ -1501,7 +1501,7 @@
           <p:cNvPr id="2" name="Заголовок 1">
             <a:extLst>
               <a:ext uri="{FF2B5EF4-FFF2-40B4-BE49-F238E27FC236}">
-                <a16:creationId xmlns:a16="http://schemas.microsoft.com/office/drawing/2014/main" id="{87B60EBB-EBC7-0D0B-98FA-A50881360EB7}"/>
+                <a16:creationId xmlns:a16="http://schemas.microsoft.com/office/drawing/2014/main" id="{B904B867-A03B-5101-7638-442572CF50E6}"/>
               </a:ext>
             </a:extLst>
           </p:cNvPr>
@@ -1534,7 +1534,7 @@
           <p:cNvPr id="3" name="Текст 2">
             <a:extLst>
               <a:ext uri="{FF2B5EF4-FFF2-40B4-BE49-F238E27FC236}">
-                <a16:creationId xmlns:a16="http://schemas.microsoft.com/office/drawing/2014/main" id="{9050CE4E-E80C-71E4-E18F-FE1DDD4E6813}"/>
+                <a16:creationId xmlns:a16="http://schemas.microsoft.com/office/drawing/2014/main" id="{B079F521-870D-3A3C-3AD7-A2A082970893}"/>
               </a:ext>
             </a:extLst>
           </p:cNvPr>
@@ -1605,7 +1605,7 @@
           <p:cNvPr id="4" name="Объект 3">
             <a:extLst>
               <a:ext uri="{FF2B5EF4-FFF2-40B4-BE49-F238E27FC236}">
-                <a16:creationId xmlns:a16="http://schemas.microsoft.com/office/drawing/2014/main" id="{80989572-F283-EAA2-C5E9-DC23AAF84D2A}"/>
+                <a16:creationId xmlns:a16="http://schemas.microsoft.com/office/drawing/2014/main" id="{7A4884EF-C7D6-EF74-E88F-4FCD81E20115}"/>
               </a:ext>
             </a:extLst>
           </p:cNvPr>
@@ -1667,7 +1667,7 @@
           <p:cNvPr id="5" name="Текст 4">
             <a:extLst>
               <a:ext uri="{FF2B5EF4-FFF2-40B4-BE49-F238E27FC236}">
-                <a16:creationId xmlns:a16="http://schemas.microsoft.com/office/drawing/2014/main" id="{A8EE7B4B-EDAB-BD04-B5B0-E294629F279A}"/>
+                <a16:creationId xmlns:a16="http://schemas.microsoft.com/office/drawing/2014/main" id="{7E7B92C6-F640-34F3-F32E-89AF6A4DC827}"/>
               </a:ext>
             </a:extLst>
           </p:cNvPr>
@@ -1738,7 +1738,7 @@
           <p:cNvPr id="6" name="Объект 5">
             <a:extLst>
               <a:ext uri="{FF2B5EF4-FFF2-40B4-BE49-F238E27FC236}">
-                <a16:creationId xmlns:a16="http://schemas.microsoft.com/office/drawing/2014/main" id="{4C97E1A5-5414-8A66-FE02-12339B1B744C}"/>
+                <a16:creationId xmlns:a16="http://schemas.microsoft.com/office/drawing/2014/main" id="{E9C10694-0DC2-78C8-5036-832921F0D9E3}"/>
               </a:ext>
             </a:extLst>
           </p:cNvPr>
@@ -1800,7 +1800,7 @@
           <p:cNvPr id="7" name="Дата 6">
             <a:extLst>
               <a:ext uri="{FF2B5EF4-FFF2-40B4-BE49-F238E27FC236}">
-                <a16:creationId xmlns:a16="http://schemas.microsoft.com/office/drawing/2014/main" id="{F2985F4B-6FFE-CC1B-8541-0A26F85A5765}"/>
+                <a16:creationId xmlns:a16="http://schemas.microsoft.com/office/drawing/2014/main" id="{7D494726-431A-700A-A9BE-B1A6DDF85628}"/>
               </a:ext>
             </a:extLst>
           </p:cNvPr>
@@ -1816,9 +1816,9 @@
           <a:bodyPr/>
           <a:lstStyle/>
           <a:p>
-            <a:fld id="{44447AD5-A860-4F74-86B1-0034733D12B0}" type="datetimeFigureOut">
+            <a:fld id="{FECAD547-0098-4F95-A3E6-B35FDCDAFEB6}" type="datetimeFigureOut">
               <a:rPr lang="ru-RU" smtClean="0"/>
-              <a:t>21.10.2026</a:t>
+              <a:t>22.10.2026</a:t>
             </a:fld>
             <a:endParaRPr lang="ru-RU"/>
           </a:p>
@@ -1829,7 +1829,7 @@
           <p:cNvPr id="8" name="Нижний колонтитул 7">
             <a:extLst>
               <a:ext uri="{FF2B5EF4-FFF2-40B4-BE49-F238E27FC236}">
-                <a16:creationId xmlns:a16="http://schemas.microsoft.com/office/drawing/2014/main" id="{5F36477C-910E-1D9A-440E-05D93536D36F}"/>
+                <a16:creationId xmlns:a16="http://schemas.microsoft.com/office/drawing/2014/main" id="{D266C023-72A8-15D0-792D-7119458DEBB0}"/>
               </a:ext>
             </a:extLst>
           </p:cNvPr>
@@ -1854,7 +1854,7 @@
           <p:cNvPr id="9" name="Номер слайда 8">
             <a:extLst>
               <a:ext uri="{FF2B5EF4-FFF2-40B4-BE49-F238E27FC236}">
-                <a16:creationId xmlns:a16="http://schemas.microsoft.com/office/drawing/2014/main" id="{4328669F-AF11-088B-D1A9-F3AD66BAD2C0}"/>
+                <a16:creationId xmlns:a16="http://schemas.microsoft.com/office/drawing/2014/main" id="{69700F1C-5A3E-C93F-51B6-676A2F13AA35}"/>
               </a:ext>
             </a:extLst>
           </p:cNvPr>
@@ -1870,7 +1870,7 @@
           <a:bodyPr/>
           <a:lstStyle/>
           <a:p>
-            <a:fld id="{D99F9743-DED8-4E9C-BD89-EA992B299253}" type="slidenum">
+            <a:fld id="{14248956-2374-48B4-B20B-A1021DAEFE0D}" type="slidenum">
               <a:rPr lang="ru-RU" smtClean="0"/>
               <a:t>‹#›</a:t>
             </a:fld>
@@ -1881,7 +1881,7 @@
     </p:spTree>
     <p:extLst>
       <p:ext uri="{BB962C8B-B14F-4D97-AF65-F5344CB8AC3E}">
-        <p14:creationId xmlns:p14="http://schemas.microsoft.com/office/powerpoint/2010/main" val="1618633908"/>
+        <p14:creationId xmlns:p14="http://schemas.microsoft.com/office/powerpoint/2010/main" val="1594870660"/>
       </p:ext>
     </p:extLst>
   </p:cSld>
@@ -1913,7 +1913,7 @@
           <p:cNvPr id="2" name="Заголовок 1">
             <a:extLst>
               <a:ext uri="{FF2B5EF4-FFF2-40B4-BE49-F238E27FC236}">
-                <a16:creationId xmlns:a16="http://schemas.microsoft.com/office/drawing/2014/main" id="{AA17C945-920D-813A-8135-3139D62214C5}"/>
+                <a16:creationId xmlns:a16="http://schemas.microsoft.com/office/drawing/2014/main" id="{63283DB1-7DB4-7F33-CDD7-9CEED3292B42}"/>
               </a:ext>
             </a:extLst>
           </p:cNvPr>
@@ -1941,7 +1941,7 @@
           <p:cNvPr id="3" name="Дата 2">
             <a:extLst>
               <a:ext uri="{FF2B5EF4-FFF2-40B4-BE49-F238E27FC236}">
-                <a16:creationId xmlns:a16="http://schemas.microsoft.com/office/drawing/2014/main" id="{0D4FF71F-9A2A-98B1-89CE-64875BF8750F}"/>
+                <a16:creationId xmlns:a16="http://schemas.microsoft.com/office/drawing/2014/main" id="{80FC06F1-4C81-93D3-24B6-B6391D0E0005}"/>
               </a:ext>
             </a:extLst>
           </p:cNvPr>
@@ -1957,9 +1957,9 @@
           <a:bodyPr/>
           <a:lstStyle/>
           <a:p>
-            <a:fld id="{44447AD5-A860-4F74-86B1-0034733D12B0}" type="datetimeFigureOut">
+            <a:fld id="{FECAD547-0098-4F95-A3E6-B35FDCDAFEB6}" type="datetimeFigureOut">
               <a:rPr lang="ru-RU" smtClean="0"/>
-              <a:t>21.10.2026</a:t>
+              <a:t>22.10.2026</a:t>
             </a:fld>
             <a:endParaRPr lang="ru-RU"/>
           </a:p>
@@ -1970,7 +1970,7 @@
           <p:cNvPr id="4" name="Нижний колонтитул 3">
             <a:extLst>
               <a:ext uri="{FF2B5EF4-FFF2-40B4-BE49-F238E27FC236}">
-                <a16:creationId xmlns:a16="http://schemas.microsoft.com/office/drawing/2014/main" id="{BDFCCB03-9850-901A-AB15-73EC217A7C57}"/>
+                <a16:creationId xmlns:a16="http://schemas.microsoft.com/office/drawing/2014/main" id="{A30F401A-A942-2FAD-6DEF-2AE49CAC5980}"/>
               </a:ext>
             </a:extLst>
           </p:cNvPr>
@@ -1995,7 +1995,7 @@
           <p:cNvPr id="5" name="Номер слайда 4">
             <a:extLst>
               <a:ext uri="{FF2B5EF4-FFF2-40B4-BE49-F238E27FC236}">
-                <a16:creationId xmlns:a16="http://schemas.microsoft.com/office/drawing/2014/main" id="{931AC97D-FAD1-611D-7D9E-F35E002C54BB}"/>
+                <a16:creationId xmlns:a16="http://schemas.microsoft.com/office/drawing/2014/main" id="{4DC91934-5B27-BEAA-64F9-C18DC95331F5}"/>
               </a:ext>
             </a:extLst>
           </p:cNvPr>
@@ -2011,7 +2011,7 @@
           <a:bodyPr/>
           <a:lstStyle/>
           <a:p>
-            <a:fld id="{D99F9743-DED8-4E9C-BD89-EA992B299253}" type="slidenum">
+            <a:fld id="{14248956-2374-48B4-B20B-A1021DAEFE0D}" type="slidenum">
               <a:rPr lang="ru-RU" smtClean="0"/>
               <a:t>‹#›</a:t>
             </a:fld>
@@ -2022,7 +2022,7 @@
     </p:spTree>
     <p:extLst>
       <p:ext uri="{BB962C8B-B14F-4D97-AF65-F5344CB8AC3E}">
-        <p14:creationId xmlns:p14="http://schemas.microsoft.com/office/powerpoint/2010/main" val="528829987"/>
+        <p14:creationId xmlns:p14="http://schemas.microsoft.com/office/powerpoint/2010/main" val="4078596708"/>
       </p:ext>
     </p:extLst>
   </p:cSld>
@@ -2054,7 +2054,7 @@
           <p:cNvPr id="2" name="Дата 1">
             <a:extLst>
               <a:ext uri="{FF2B5EF4-FFF2-40B4-BE49-F238E27FC236}">
-                <a16:creationId xmlns:a16="http://schemas.microsoft.com/office/drawing/2014/main" id="{0D36D7B2-63B0-6E3B-49DD-A3D78850E45F}"/>
+                <a16:creationId xmlns:a16="http://schemas.microsoft.com/office/drawing/2014/main" id="{8BF4F305-DF00-9237-67B5-749A0CEB2ECF}"/>
               </a:ext>
             </a:extLst>
           </p:cNvPr>
@@ -2070,9 +2070,9 @@
           <a:bodyPr/>
           <a:lstStyle/>
           <a:p>
-            <a:fld id="{44447AD5-A860-4F74-86B1-0034733D12B0}" type="datetimeFigureOut">
+            <a:fld id="{FECAD547-0098-4F95-A3E6-B35FDCDAFEB6}" type="datetimeFigureOut">
               <a:rPr lang="ru-RU" smtClean="0"/>
-              <a:t>21.10.2026</a:t>
+              <a:t>22.10.2026</a:t>
             </a:fld>
             <a:endParaRPr lang="ru-RU"/>
           </a:p>
@@ -2083,7 +2083,7 @@
           <p:cNvPr id="3" name="Нижний колонтитул 2">
             <a:extLst>
               <a:ext uri="{FF2B5EF4-FFF2-40B4-BE49-F238E27FC236}">
-                <a16:creationId xmlns:a16="http://schemas.microsoft.com/office/drawing/2014/main" id="{ACE10BBD-FFE7-3614-E133-C5261CBE6B9A}"/>
+                <a16:creationId xmlns:a16="http://schemas.microsoft.com/office/drawing/2014/main" id="{EABC8274-FF22-F942-6F1F-B77240049EC3}"/>
               </a:ext>
             </a:extLst>
           </p:cNvPr>
@@ -2108,7 +2108,7 @@
           <p:cNvPr id="4" name="Номер слайда 3">
             <a:extLst>
               <a:ext uri="{FF2B5EF4-FFF2-40B4-BE49-F238E27FC236}">
-                <a16:creationId xmlns:a16="http://schemas.microsoft.com/office/drawing/2014/main" id="{74F81673-5ABC-2321-FC57-73EABB79EC39}"/>
+                <a16:creationId xmlns:a16="http://schemas.microsoft.com/office/drawing/2014/main" id="{BD8D32A2-D60B-F554-9D6E-CF146796151C}"/>
               </a:ext>
             </a:extLst>
           </p:cNvPr>
@@ -2124,7 +2124,7 @@
           <a:bodyPr/>
           <a:lstStyle/>
           <a:p>
-            <a:fld id="{D99F9743-DED8-4E9C-BD89-EA992B299253}" type="slidenum">
+            <a:fld id="{14248956-2374-48B4-B20B-A1021DAEFE0D}" type="slidenum">
               <a:rPr lang="ru-RU" smtClean="0"/>
               <a:t>‹#›</a:t>
             </a:fld>
@@ -2135,7 +2135,7 @@
     </p:spTree>
     <p:extLst>
       <p:ext uri="{BB962C8B-B14F-4D97-AF65-F5344CB8AC3E}">
-        <p14:creationId xmlns:p14="http://schemas.microsoft.com/office/powerpoint/2010/main" val="3458436300"/>
+        <p14:creationId xmlns:p14="http://schemas.microsoft.com/office/powerpoint/2010/main" val="395164118"/>
       </p:ext>
     </p:extLst>
   </p:cSld>
@@ -2167,7 +2167,7 @@
           <p:cNvPr id="2" name="Заголовок 1">
             <a:extLst>
               <a:ext uri="{FF2B5EF4-FFF2-40B4-BE49-F238E27FC236}">
-                <a16:creationId xmlns:a16="http://schemas.microsoft.com/office/drawing/2014/main" id="{9513B0BF-A7FC-A544-74B7-E9648E58CBCB}"/>
+                <a16:creationId xmlns:a16="http://schemas.microsoft.com/office/drawing/2014/main" id="{060A5FD7-4A18-508A-FFF9-6ABB891E66E0}"/>
               </a:ext>
             </a:extLst>
           </p:cNvPr>
@@ -2204,7 +2204,7 @@
           <p:cNvPr id="3" name="Объект 2">
             <a:extLst>
               <a:ext uri="{FF2B5EF4-FFF2-40B4-BE49-F238E27FC236}">
-                <a16:creationId xmlns:a16="http://schemas.microsoft.com/office/drawing/2014/main" id="{11FCABD1-745F-FBF1-AFD1-685BE03FF9BA}"/>
+                <a16:creationId xmlns:a16="http://schemas.microsoft.com/office/drawing/2014/main" id="{1DC83CE2-1B0B-8E84-8F96-B1D94D62D486}"/>
               </a:ext>
             </a:extLst>
           </p:cNvPr>
@@ -2294,7 +2294,7 @@
           <p:cNvPr id="4" name="Текст 3">
             <a:extLst>
               <a:ext uri="{FF2B5EF4-FFF2-40B4-BE49-F238E27FC236}">
-                <a16:creationId xmlns:a16="http://schemas.microsoft.com/office/drawing/2014/main" id="{6DFB6E9E-589B-6746-BD55-21782DD24FAE}"/>
+                <a16:creationId xmlns:a16="http://schemas.microsoft.com/office/drawing/2014/main" id="{9D492F47-04AC-287A-E2BE-6968902D1C3E}"/>
               </a:ext>
             </a:extLst>
           </p:cNvPr>
@@ -2365,7 +2365,7 @@
           <p:cNvPr id="5" name="Дата 4">
             <a:extLst>
               <a:ext uri="{FF2B5EF4-FFF2-40B4-BE49-F238E27FC236}">
-                <a16:creationId xmlns:a16="http://schemas.microsoft.com/office/drawing/2014/main" id="{377664C4-103C-3691-98C8-2C6CADCD1E1A}"/>
+                <a16:creationId xmlns:a16="http://schemas.microsoft.com/office/drawing/2014/main" id="{EE20D621-7CB6-70D8-8BB0-20A169C8E4E3}"/>
               </a:ext>
             </a:extLst>
           </p:cNvPr>
@@ -2381,9 +2381,9 @@
           <a:bodyPr/>
           <a:lstStyle/>
           <a:p>
-            <a:fld id="{44447AD5-A860-4F74-86B1-0034733D12B0}" type="datetimeFigureOut">
+            <a:fld id="{FECAD547-0098-4F95-A3E6-B35FDCDAFEB6}" type="datetimeFigureOut">
               <a:rPr lang="ru-RU" smtClean="0"/>
-              <a:t>21.10.2026</a:t>
+              <a:t>22.10.2026</a:t>
             </a:fld>
             <a:endParaRPr lang="ru-RU"/>
           </a:p>
@@ -2394,7 +2394,7 @@
           <p:cNvPr id="6" name="Нижний колонтитул 5">
             <a:extLst>
               <a:ext uri="{FF2B5EF4-FFF2-40B4-BE49-F238E27FC236}">
-                <a16:creationId xmlns:a16="http://schemas.microsoft.com/office/drawing/2014/main" id="{C3109FB1-12DE-BD7E-E382-17C4654BEC10}"/>
+                <a16:creationId xmlns:a16="http://schemas.microsoft.com/office/drawing/2014/main" id="{E46CAA40-3AF4-539C-1896-B514540EC26F}"/>
               </a:ext>
             </a:extLst>
           </p:cNvPr>
@@ -2419,7 +2419,7 @@
           <p:cNvPr id="7" name="Номер слайда 6">
             <a:extLst>
               <a:ext uri="{FF2B5EF4-FFF2-40B4-BE49-F238E27FC236}">
-                <a16:creationId xmlns:a16="http://schemas.microsoft.com/office/drawing/2014/main" id="{32239CA3-159B-9E36-B5D1-071E81155321}"/>
+                <a16:creationId xmlns:a16="http://schemas.microsoft.com/office/drawing/2014/main" id="{76572272-55E7-DBE8-1501-9210A55F25A8}"/>
               </a:ext>
             </a:extLst>
           </p:cNvPr>
@@ -2435,7 +2435,7 @@
           <a:bodyPr/>
           <a:lstStyle/>
           <a:p>
-            <a:fld id="{D99F9743-DED8-4E9C-BD89-EA992B299253}" type="slidenum">
+            <a:fld id="{14248956-2374-48B4-B20B-A1021DAEFE0D}" type="slidenum">
               <a:rPr lang="ru-RU" smtClean="0"/>
               <a:t>‹#›</a:t>
             </a:fld>
@@ -2446,7 +2446,7 @@
     </p:spTree>
     <p:extLst>
       <p:ext uri="{BB962C8B-B14F-4D97-AF65-F5344CB8AC3E}">
-        <p14:creationId xmlns:p14="http://schemas.microsoft.com/office/powerpoint/2010/main" val="1763266337"/>
+        <p14:creationId xmlns:p14="http://schemas.microsoft.com/office/powerpoint/2010/main" val="1860773389"/>
       </p:ext>
     </p:extLst>
   </p:cSld>
@@ -2478,7 +2478,7 @@
           <p:cNvPr id="2" name="Заголовок 1">
             <a:extLst>
               <a:ext uri="{FF2B5EF4-FFF2-40B4-BE49-F238E27FC236}">
-                <a16:creationId xmlns:a16="http://schemas.microsoft.com/office/drawing/2014/main" id="{15B783A7-E1EF-D25A-F748-4A2DF166A002}"/>
+                <a16:creationId xmlns:a16="http://schemas.microsoft.com/office/drawing/2014/main" id="{A6C708DA-3DCE-0BAA-4ECD-89C680ABD730}"/>
               </a:ext>
             </a:extLst>
           </p:cNvPr>
@@ -2515,7 +2515,7 @@
           <p:cNvPr id="3" name="Рисунок 2">
             <a:extLst>
               <a:ext uri="{FF2B5EF4-FFF2-40B4-BE49-F238E27FC236}">
-                <a16:creationId xmlns:a16="http://schemas.microsoft.com/office/drawing/2014/main" id="{0B75E683-3761-6D1D-0727-EC3D1E512B03}"/>
+                <a16:creationId xmlns:a16="http://schemas.microsoft.com/office/drawing/2014/main" id="{42938E84-07FA-3750-EA71-F6FC74E4BA95}"/>
               </a:ext>
             </a:extLst>
           </p:cNvPr>
@@ -2582,7 +2582,7 @@
           <p:cNvPr id="4" name="Текст 3">
             <a:extLst>
               <a:ext uri="{FF2B5EF4-FFF2-40B4-BE49-F238E27FC236}">
-                <a16:creationId xmlns:a16="http://schemas.microsoft.com/office/drawing/2014/main" id="{3D7A4650-A5BA-C70E-02E6-1040318FC025}"/>
+                <a16:creationId xmlns:a16="http://schemas.microsoft.com/office/drawing/2014/main" id="{C2ADF9FA-B65B-85C6-6AB5-8DFD3700DB30}"/>
               </a:ext>
             </a:extLst>
           </p:cNvPr>
@@ -2653,7 +2653,7 @@
           <p:cNvPr id="5" name="Дата 4">
             <a:extLst>
               <a:ext uri="{FF2B5EF4-FFF2-40B4-BE49-F238E27FC236}">
-                <a16:creationId xmlns:a16="http://schemas.microsoft.com/office/drawing/2014/main" id="{3634C4A0-264A-6ADB-CB0B-86079E9ECCFE}"/>
+                <a16:creationId xmlns:a16="http://schemas.microsoft.com/office/drawing/2014/main" id="{22FA9EFC-EC0B-6302-F593-209B23751E5E}"/>
               </a:ext>
             </a:extLst>
           </p:cNvPr>
@@ -2669,9 +2669,9 @@
           <a:bodyPr/>
           <a:lstStyle/>
           <a:p>
-            <a:fld id="{44447AD5-A860-4F74-86B1-0034733D12B0}" type="datetimeFigureOut">
+            <a:fld id="{FECAD547-0098-4F95-A3E6-B35FDCDAFEB6}" type="datetimeFigureOut">
               <a:rPr lang="ru-RU" smtClean="0"/>
-              <a:t>21.10.2026</a:t>
+              <a:t>22.10.2026</a:t>
             </a:fld>
             <a:endParaRPr lang="ru-RU"/>
           </a:p>
@@ -2682,7 +2682,7 @@
           <p:cNvPr id="6" name="Нижний колонтитул 5">
             <a:extLst>
               <a:ext uri="{FF2B5EF4-FFF2-40B4-BE49-F238E27FC236}">
-                <a16:creationId xmlns:a16="http://schemas.microsoft.com/office/drawing/2014/main" id="{50AF0235-26BF-52FC-C5D0-9653D09823AC}"/>
+                <a16:creationId xmlns:a16="http://schemas.microsoft.com/office/drawing/2014/main" id="{5029CF42-5A97-CAC6-6580-7CE6E784362D}"/>
               </a:ext>
             </a:extLst>
           </p:cNvPr>
@@ -2707,7 +2707,7 @@
           <p:cNvPr id="7" name="Номер слайда 6">
             <a:extLst>
               <a:ext uri="{FF2B5EF4-FFF2-40B4-BE49-F238E27FC236}">
-                <a16:creationId xmlns:a16="http://schemas.microsoft.com/office/drawing/2014/main" id="{829166BC-0A4A-F0EC-F5E3-B3002D4139AC}"/>
+                <a16:creationId xmlns:a16="http://schemas.microsoft.com/office/drawing/2014/main" id="{1117878A-FCDA-B547-2897-0C175066CF9D}"/>
               </a:ext>
             </a:extLst>
           </p:cNvPr>
@@ -2723,7 +2723,7 @@
           <a:bodyPr/>
           <a:lstStyle/>
           <a:p>
-            <a:fld id="{D99F9743-DED8-4E9C-BD89-EA992B299253}" type="slidenum">
+            <a:fld id="{14248956-2374-48B4-B20B-A1021DAEFE0D}" type="slidenum">
               <a:rPr lang="ru-RU" smtClean="0"/>
               <a:t>‹#›</a:t>
             </a:fld>
@@ -2734,7 +2734,7 @@
     </p:spTree>
     <p:extLst>
       <p:ext uri="{BB962C8B-B14F-4D97-AF65-F5344CB8AC3E}">
-        <p14:creationId xmlns:p14="http://schemas.microsoft.com/office/powerpoint/2010/main" val="1600449889"/>
+        <p14:creationId xmlns:p14="http://schemas.microsoft.com/office/powerpoint/2010/main" val="242300011"/>
       </p:ext>
     </p:extLst>
   </p:cSld>
@@ -2771,7 +2771,7 @@
           <p:cNvPr id="2" name="Заголовок 1">
             <a:extLst>
               <a:ext uri="{FF2B5EF4-FFF2-40B4-BE49-F238E27FC236}">
-                <a16:creationId xmlns:a16="http://schemas.microsoft.com/office/drawing/2014/main" id="{DC8AD4CD-731D-CBB1-E9C2-F59C87734604}"/>
+                <a16:creationId xmlns:a16="http://schemas.microsoft.com/office/drawing/2014/main" id="{72F54835-A4C5-B2CA-EC34-F7FF1DC53C34}"/>
               </a:ext>
             </a:extLst>
           </p:cNvPr>
@@ -2809,7 +2809,7 @@
           <p:cNvPr id="3" name="Текст 2">
             <a:extLst>
               <a:ext uri="{FF2B5EF4-FFF2-40B4-BE49-F238E27FC236}">
-                <a16:creationId xmlns:a16="http://schemas.microsoft.com/office/drawing/2014/main" id="{632B7CE7-9EBF-5396-B9AA-DA2BF9506897}"/>
+                <a16:creationId xmlns:a16="http://schemas.microsoft.com/office/drawing/2014/main" id="{B834371C-9D98-8075-0551-B425FA73387D}"/>
               </a:ext>
             </a:extLst>
           </p:cNvPr>
@@ -2876,7 +2876,7 @@
           <p:cNvPr id="4" name="Дата 3">
             <a:extLst>
               <a:ext uri="{FF2B5EF4-FFF2-40B4-BE49-F238E27FC236}">
-                <a16:creationId xmlns:a16="http://schemas.microsoft.com/office/drawing/2014/main" id="{5A03B0F9-F340-5E36-3F35-E0FDDA51980D}"/>
+                <a16:creationId xmlns:a16="http://schemas.microsoft.com/office/drawing/2014/main" id="{77CB833D-E313-2110-A3CB-01BF873F6F01}"/>
               </a:ext>
             </a:extLst>
           </p:cNvPr>
@@ -2910,9 +2910,9 @@
             </a:lvl1pPr>
           </a:lstStyle>
           <a:p>
-            <a:fld id="{44447AD5-A860-4F74-86B1-0034733D12B0}" type="datetimeFigureOut">
+            <a:fld id="{FECAD547-0098-4F95-A3E6-B35FDCDAFEB6}" type="datetimeFigureOut">
               <a:rPr lang="ru-RU" smtClean="0"/>
-              <a:t>21.10.2026</a:t>
+              <a:t>22.10.2026</a:t>
             </a:fld>
             <a:endParaRPr lang="ru-RU"/>
           </a:p>
@@ -2923,7 +2923,7 @@
           <p:cNvPr id="5" name="Нижний колонтитул 4">
             <a:extLst>
               <a:ext uri="{FF2B5EF4-FFF2-40B4-BE49-F238E27FC236}">
-                <a16:creationId xmlns:a16="http://schemas.microsoft.com/office/drawing/2014/main" id="{E526F631-F5AE-B6E7-EEE8-3D26D48004CB}"/>
+                <a16:creationId xmlns:a16="http://schemas.microsoft.com/office/drawing/2014/main" id="{AD0A2E83-E5AF-0EB3-958F-5FFD5BF9BE8C}"/>
               </a:ext>
             </a:extLst>
           </p:cNvPr>
@@ -2966,7 +2966,7 @@
           <p:cNvPr id="6" name="Номер слайда 5">
             <a:extLst>
               <a:ext uri="{FF2B5EF4-FFF2-40B4-BE49-F238E27FC236}">
-                <a16:creationId xmlns:a16="http://schemas.microsoft.com/office/drawing/2014/main" id="{CE98507B-0F96-CC7B-82C7-9947F9C9363E}"/>
+                <a16:creationId xmlns:a16="http://schemas.microsoft.com/office/drawing/2014/main" id="{7B53B29B-37EC-7ADE-1BB2-BB9B889DD812}"/>
               </a:ext>
             </a:extLst>
           </p:cNvPr>
@@ -3000,7 +3000,7 @@
             </a:lvl1pPr>
           </a:lstStyle>
           <a:p>
-            <a:fld id="{D99F9743-DED8-4E9C-BD89-EA992B299253}" type="slidenum">
+            <a:fld id="{14248956-2374-48B4-B20B-A1021DAEFE0D}" type="slidenum">
               <a:rPr lang="ru-RU" smtClean="0"/>
               <a:t>‹#›</a:t>
             </a:fld>
@@ -3011,7 +3011,7 @@
     </p:spTree>
     <p:extLst>
       <p:ext uri="{BB962C8B-B14F-4D97-AF65-F5344CB8AC3E}">
-        <p14:creationId xmlns:p14="http://schemas.microsoft.com/office/powerpoint/2010/main" val="4225137624"/>
+        <p14:creationId xmlns:p14="http://schemas.microsoft.com/office/powerpoint/2010/main" val="1120260318"/>
       </p:ext>
     </p:extLst>
   </p:cSld>
@@ -3334,7 +3334,7 @@
           <p:cNvPr id="2" name="Прямоугольник 1">
             <a:extLst>
               <a:ext uri="{FF2B5EF4-FFF2-40B4-BE49-F238E27FC236}">
-                <a16:creationId xmlns:a16="http://schemas.microsoft.com/office/drawing/2014/main" id="{EDC73865-515B-15F7-63B2-10458427DF64}"/>
+                <a16:creationId xmlns:a16="http://schemas.microsoft.com/office/drawing/2014/main" id="{7F5BEB85-AEC1-366B-069D-096A8E4CB906}"/>
               </a:ext>
             </a:extLst>
           </p:cNvPr>
@@ -3402,7 +3402,7 @@
           <p:cNvPr id="3" name="Прямоугольник 2">
             <a:extLst>
               <a:ext uri="{FF2B5EF4-FFF2-40B4-BE49-F238E27FC236}">
-                <a16:creationId xmlns:a16="http://schemas.microsoft.com/office/drawing/2014/main" id="{795C27E7-CD7F-4CC9-852A-A7A0D114A471}"/>
+                <a16:creationId xmlns:a16="http://schemas.microsoft.com/office/drawing/2014/main" id="{849DC070-7F2B-6FB8-2265-4E6098203005}"/>
               </a:ext>
             </a:extLst>
           </p:cNvPr>
@@ -3470,7 +3470,7 @@
           <p:cNvPr id="4" name="Прямоугольник 3">
             <a:extLst>
               <a:ext uri="{FF2B5EF4-FFF2-40B4-BE49-F238E27FC236}">
-                <a16:creationId xmlns:a16="http://schemas.microsoft.com/office/drawing/2014/main" id="{DECE2BB2-5953-72D0-FAE9-DA94999E760E}"/>
+                <a16:creationId xmlns:a16="http://schemas.microsoft.com/office/drawing/2014/main" id="{14065CA6-1321-A3EE-FC52-9D057D8DB114}"/>
               </a:ext>
             </a:extLst>
           </p:cNvPr>
@@ -3538,7 +3538,7 @@
           <p:cNvPr id="5" name="TextBox 4">
             <a:extLst>
               <a:ext uri="{FF2B5EF4-FFF2-40B4-BE49-F238E27FC236}">
-                <a16:creationId xmlns:a16="http://schemas.microsoft.com/office/drawing/2014/main" id="{6EBD3D4E-7D4F-3DB6-428D-057627FCB9D4}"/>
+                <a16:creationId xmlns:a16="http://schemas.microsoft.com/office/drawing/2014/main" id="{A0360FAD-3AB8-7959-7BD2-3E952459A4FB}"/>
               </a:ext>
             </a:extLst>
           </p:cNvPr>
@@ -3578,7 +3578,7 @@
           <p:cNvPr id="6" name="TextBox 5">
             <a:extLst>
               <a:ext uri="{FF2B5EF4-FFF2-40B4-BE49-F238E27FC236}">
-                <a16:creationId xmlns:a16="http://schemas.microsoft.com/office/drawing/2014/main" id="{A2CF301B-5E4A-D2C3-6B4A-5E89C8321FD9}"/>
+                <a16:creationId xmlns:a16="http://schemas.microsoft.com/office/drawing/2014/main" id="{787B28FB-A636-26C4-A550-F5D65D83164E}"/>
               </a:ext>
             </a:extLst>
           </p:cNvPr>
@@ -3618,7 +3618,7 @@
           <p:cNvPr id="7" name="TextBox 6">
             <a:extLst>
               <a:ext uri="{FF2B5EF4-FFF2-40B4-BE49-F238E27FC236}">
-                <a16:creationId xmlns:a16="http://schemas.microsoft.com/office/drawing/2014/main" id="{AB2E4724-D950-BFE8-BFBB-0B1F9DBC4825}"/>
+                <a16:creationId xmlns:a16="http://schemas.microsoft.com/office/drawing/2014/main" id="{7A54CAED-A2E1-F185-B36D-660F55DA12F3}"/>
               </a:ext>
             </a:extLst>
           </p:cNvPr>
@@ -3658,7 +3658,7 @@
           <p:cNvPr id="8" name="TextBox 7">
             <a:extLst>
               <a:ext uri="{FF2B5EF4-FFF2-40B4-BE49-F238E27FC236}">
-                <a16:creationId xmlns:a16="http://schemas.microsoft.com/office/drawing/2014/main" id="{53E9F525-5F5B-5313-6BB6-229243849DE5}"/>
+                <a16:creationId xmlns:a16="http://schemas.microsoft.com/office/drawing/2014/main" id="{78545C19-D375-A779-3D27-D40842666C78}"/>
               </a:ext>
             </a:extLst>
           </p:cNvPr>
@@ -3698,7 +3698,7 @@
           <p:cNvPr id="9" name="TextBox 8">
             <a:extLst>
               <a:ext uri="{FF2B5EF4-FFF2-40B4-BE49-F238E27FC236}">
-                <a16:creationId xmlns:a16="http://schemas.microsoft.com/office/drawing/2014/main" id="{A38D095D-E794-2911-CF25-758967BCDF73}"/>
+                <a16:creationId xmlns:a16="http://schemas.microsoft.com/office/drawing/2014/main" id="{E1073DBC-E3D7-FA20-9F45-E9B5F7DD85BE}"/>
               </a:ext>
             </a:extLst>
           </p:cNvPr>
@@ -3738,7 +3738,7 @@
           <p:cNvPr id="10" name="TextBox 9">
             <a:extLst>
               <a:ext uri="{FF2B5EF4-FFF2-40B4-BE49-F238E27FC236}">
-                <a16:creationId xmlns:a16="http://schemas.microsoft.com/office/drawing/2014/main" id="{7505444F-4E5A-A8F1-F3FB-8A1E55EAA587}"/>
+                <a16:creationId xmlns:a16="http://schemas.microsoft.com/office/drawing/2014/main" id="{9B3A0312-075F-CE99-7A61-AC789AD8F0DA}"/>
               </a:ext>
             </a:extLst>
           </p:cNvPr>
@@ -3778,7 +3778,7 @@
           <p:cNvPr id="11" name="Прямоугольник 10">
             <a:extLst>
               <a:ext uri="{FF2B5EF4-FFF2-40B4-BE49-F238E27FC236}">
-                <a16:creationId xmlns:a16="http://schemas.microsoft.com/office/drawing/2014/main" id="{339CF863-1029-D93A-AAE2-C58AA46FBC7C}"/>
+                <a16:creationId xmlns:a16="http://schemas.microsoft.com/office/drawing/2014/main" id="{511F0877-5EDE-830B-415B-6AF88F80C526}"/>
               </a:ext>
             </a:extLst>
           </p:cNvPr>
@@ -3846,7 +3846,7 @@
           <p:cNvPr id="12" name="TextBox 11">
             <a:extLst>
               <a:ext uri="{FF2B5EF4-FFF2-40B4-BE49-F238E27FC236}">
-                <a16:creationId xmlns:a16="http://schemas.microsoft.com/office/drawing/2014/main" id="{D0A82BD7-16DD-1AC6-3B1F-033FD8CB6B56}"/>
+                <a16:creationId xmlns:a16="http://schemas.microsoft.com/office/drawing/2014/main" id="{E8112DA3-CB48-3690-106B-ADEEAEDF290C}"/>
               </a:ext>
             </a:extLst>
           </p:cNvPr>
@@ -3886,7 +3886,7 @@
           <p:cNvPr id="13" name="TextBox 12">
             <a:extLst>
               <a:ext uri="{FF2B5EF4-FFF2-40B4-BE49-F238E27FC236}">
-                <a16:creationId xmlns:a16="http://schemas.microsoft.com/office/drawing/2014/main" id="{6186943B-6A56-B27F-0A3B-F541DC06AC14}"/>
+                <a16:creationId xmlns:a16="http://schemas.microsoft.com/office/drawing/2014/main" id="{06DDB76F-9CBB-5FD1-15D5-039AEB4C4C60}"/>
               </a:ext>
             </a:extLst>
           </p:cNvPr>
@@ -3926,7 +3926,7 @@
           <p:cNvPr id="14" name="TextBox 13">
             <a:extLst>
               <a:ext uri="{FF2B5EF4-FFF2-40B4-BE49-F238E27FC236}">
-                <a16:creationId xmlns:a16="http://schemas.microsoft.com/office/drawing/2014/main" id="{3ED005CF-A89C-C514-1448-1832EC1B7613}"/>
+                <a16:creationId xmlns:a16="http://schemas.microsoft.com/office/drawing/2014/main" id="{196EA565-F5D7-C706-5CDA-51DA29F481D5}"/>
               </a:ext>
             </a:extLst>
           </p:cNvPr>
@@ -3966,7 +3966,7 @@
           <p:cNvPr id="15" name="TextBox 14">
             <a:extLst>
               <a:ext uri="{FF2B5EF4-FFF2-40B4-BE49-F238E27FC236}">
-                <a16:creationId xmlns:a16="http://schemas.microsoft.com/office/drawing/2014/main" id="{9E9F1D55-245A-294E-4D15-6A4C640F20D3}"/>
+                <a16:creationId xmlns:a16="http://schemas.microsoft.com/office/drawing/2014/main" id="{89ABBC0A-3D7E-1ACB-79C2-E73A8B6DD67D}"/>
               </a:ext>
             </a:extLst>
           </p:cNvPr>
@@ -4006,7 +4006,7 @@
           <p:cNvPr id="16" name="TextBox 15">
             <a:extLst>
               <a:ext uri="{FF2B5EF4-FFF2-40B4-BE49-F238E27FC236}">
-                <a16:creationId xmlns:a16="http://schemas.microsoft.com/office/drawing/2014/main" id="{F2ECDC36-11B3-EB45-6B99-1869676A3140}"/>
+                <a16:creationId xmlns:a16="http://schemas.microsoft.com/office/drawing/2014/main" id="{117B9B7C-0685-9702-062D-BDB1C8B17AEA}"/>
               </a:ext>
             </a:extLst>
           </p:cNvPr>
@@ -4044,7 +4044,7 @@
     </p:spTree>
     <p:extLst>
       <p:ext uri="{BB962C8B-B14F-4D97-AF65-F5344CB8AC3E}">
-        <p14:creationId xmlns:p14="http://schemas.microsoft.com/office/powerpoint/2010/main" val="863728401"/>
+        <p14:creationId xmlns:p14="http://schemas.microsoft.com/office/powerpoint/2010/main" val="447090555"/>
       </p:ext>
     </p:extLst>
   </p:cSld>
@@ -4076,7 +4076,7 @@
           <p:cNvPr id="2" name="Прямоугольник 1">
             <a:extLst>
               <a:ext uri="{FF2B5EF4-FFF2-40B4-BE49-F238E27FC236}">
-                <a16:creationId xmlns:a16="http://schemas.microsoft.com/office/drawing/2014/main" id="{FE995751-E0C8-2B08-11C9-AA5E26966C53}"/>
+                <a16:creationId xmlns:a16="http://schemas.microsoft.com/office/drawing/2014/main" id="{6A84E295-B90C-2758-3AA4-6487A9FA5881}"/>
               </a:ext>
             </a:extLst>
           </p:cNvPr>
@@ -4144,7 +4144,7 @@
           <p:cNvPr id="3" name="Прямоугольник 2">
             <a:extLst>
               <a:ext uri="{FF2B5EF4-FFF2-40B4-BE49-F238E27FC236}">
-                <a16:creationId xmlns:a16="http://schemas.microsoft.com/office/drawing/2014/main" id="{F193CCEC-E598-48DC-0448-72B7D887AF78}"/>
+                <a16:creationId xmlns:a16="http://schemas.microsoft.com/office/drawing/2014/main" id="{499E128A-399D-F99D-3657-F47AF6B408DA}"/>
               </a:ext>
             </a:extLst>
           </p:cNvPr>
@@ -4212,7 +4212,7 @@
           <p:cNvPr id="4" name="TextBox 3">
             <a:extLst>
               <a:ext uri="{FF2B5EF4-FFF2-40B4-BE49-F238E27FC236}">
-                <a16:creationId xmlns:a16="http://schemas.microsoft.com/office/drawing/2014/main" id="{922C78ED-4148-124D-1826-F0288AE1C036}"/>
+                <a16:creationId xmlns:a16="http://schemas.microsoft.com/office/drawing/2014/main" id="{AF331EC8-EF84-D107-6047-822799D39D01}"/>
               </a:ext>
             </a:extLst>
           </p:cNvPr>
@@ -4252,7 +4252,7 @@
           <p:cNvPr id="5" name="TextBox 4">
             <a:extLst>
               <a:ext uri="{FF2B5EF4-FFF2-40B4-BE49-F238E27FC236}">
-                <a16:creationId xmlns:a16="http://schemas.microsoft.com/office/drawing/2014/main" id="{04CB5A10-5D53-43A7-7127-F2DB34F38A9F}"/>
+                <a16:creationId xmlns:a16="http://schemas.microsoft.com/office/drawing/2014/main" id="{974CFA31-C249-75EC-B9AB-4EE762D104F9}"/>
               </a:ext>
             </a:extLst>
           </p:cNvPr>
@@ -4293,7 +4293,7 @@
           <p:cNvPr id="6" name="Прямоугольник 5">
             <a:extLst>
               <a:ext uri="{FF2B5EF4-FFF2-40B4-BE49-F238E27FC236}">
-                <a16:creationId xmlns:a16="http://schemas.microsoft.com/office/drawing/2014/main" id="{A414FCCA-5ABD-E207-720D-7136CB384C65}"/>
+                <a16:creationId xmlns:a16="http://schemas.microsoft.com/office/drawing/2014/main" id="{C4FA9851-6B26-9335-1BDC-D034E3DF52F4}"/>
               </a:ext>
             </a:extLst>
           </p:cNvPr>
@@ -4361,7 +4361,7 @@
           <p:cNvPr id="7" name="Прямоугольник 6">
             <a:extLst>
               <a:ext uri="{FF2B5EF4-FFF2-40B4-BE49-F238E27FC236}">
-                <a16:creationId xmlns:a16="http://schemas.microsoft.com/office/drawing/2014/main" id="{417E6E92-1E74-2B42-41DC-B54AE4F26FB1}"/>
+                <a16:creationId xmlns:a16="http://schemas.microsoft.com/office/drawing/2014/main" id="{A7709913-6AAF-705F-EA3E-439507B8F3CE}"/>
               </a:ext>
             </a:extLst>
           </p:cNvPr>
@@ -4429,7 +4429,7 @@
           <p:cNvPr id="8" name="TextBox 7">
             <a:extLst>
               <a:ext uri="{FF2B5EF4-FFF2-40B4-BE49-F238E27FC236}">
-                <a16:creationId xmlns:a16="http://schemas.microsoft.com/office/drawing/2014/main" id="{F583C0B5-147A-8BDF-7CF6-44022A5B5ED8}"/>
+                <a16:creationId xmlns:a16="http://schemas.microsoft.com/office/drawing/2014/main" id="{405C7733-A35B-ED21-0699-68A5BCDB4B3E}"/>
               </a:ext>
             </a:extLst>
           </p:cNvPr>
@@ -4469,7 +4469,7 @@
           <p:cNvPr id="9" name="TextBox 8">
             <a:extLst>
               <a:ext uri="{FF2B5EF4-FFF2-40B4-BE49-F238E27FC236}">
-                <a16:creationId xmlns:a16="http://schemas.microsoft.com/office/drawing/2014/main" id="{32B6389F-11DE-F123-D39F-C1C0108B11C6}"/>
+                <a16:creationId xmlns:a16="http://schemas.microsoft.com/office/drawing/2014/main" id="{29F806FA-C107-AE53-38E3-2FC3F3A74165}"/>
               </a:ext>
             </a:extLst>
           </p:cNvPr>
@@ -4588,7 +4588,7 @@
     </p:spTree>
     <p:extLst>
       <p:ext uri="{BB962C8B-B14F-4D97-AF65-F5344CB8AC3E}">
-        <p14:creationId xmlns:p14="http://schemas.microsoft.com/office/powerpoint/2010/main" val="3639393118"/>
+        <p14:creationId xmlns:p14="http://schemas.microsoft.com/office/powerpoint/2010/main" val="684583390"/>
       </p:ext>
     </p:extLst>
   </p:cSld>
@@ -4620,7 +4620,7 @@
           <p:cNvPr id="2" name="Прямоугольник 1">
             <a:extLst>
               <a:ext uri="{FF2B5EF4-FFF2-40B4-BE49-F238E27FC236}">
-                <a16:creationId xmlns:a16="http://schemas.microsoft.com/office/drawing/2014/main" id="{93C72855-308E-D06D-4424-3966ECFF9CA1}"/>
+                <a16:creationId xmlns:a16="http://schemas.microsoft.com/office/drawing/2014/main" id="{E2DBD48E-8F87-DAE1-9C03-1665401EBBAD}"/>
               </a:ext>
             </a:extLst>
           </p:cNvPr>
@@ -4688,7 +4688,7 @@
           <p:cNvPr id="3" name="Прямоугольник 2">
             <a:extLst>
               <a:ext uri="{FF2B5EF4-FFF2-40B4-BE49-F238E27FC236}">
-                <a16:creationId xmlns:a16="http://schemas.microsoft.com/office/drawing/2014/main" id="{6C8A891F-6734-EE68-D8B4-C6AC04D63B14}"/>
+                <a16:creationId xmlns:a16="http://schemas.microsoft.com/office/drawing/2014/main" id="{9DA11DE9-3B17-A053-7AA7-1BAC1F8212EF}"/>
               </a:ext>
             </a:extLst>
           </p:cNvPr>
@@ -4756,7 +4756,7 @@
           <p:cNvPr id="4" name="TextBox 3">
             <a:extLst>
               <a:ext uri="{FF2B5EF4-FFF2-40B4-BE49-F238E27FC236}">
-                <a16:creationId xmlns:a16="http://schemas.microsoft.com/office/drawing/2014/main" id="{E64BC5E3-F0A2-BAC7-B1B8-2B9EA93AFA99}"/>
+                <a16:creationId xmlns:a16="http://schemas.microsoft.com/office/drawing/2014/main" id="{8B1E7C10-0D44-8C77-B8CE-D67B4DE85144}"/>
               </a:ext>
             </a:extLst>
           </p:cNvPr>
@@ -4796,7 +4796,7 @@
           <p:cNvPr id="5" name="TextBox 4">
             <a:extLst>
               <a:ext uri="{FF2B5EF4-FFF2-40B4-BE49-F238E27FC236}">
-                <a16:creationId xmlns:a16="http://schemas.microsoft.com/office/drawing/2014/main" id="{BBB309E3-7E63-7C86-D138-40ED5937367A}"/>
+                <a16:creationId xmlns:a16="http://schemas.microsoft.com/office/drawing/2014/main" id="{08C50EAB-2443-451F-187A-33BE4194E931}"/>
               </a:ext>
             </a:extLst>
           </p:cNvPr>
@@ -4837,7 +4837,7 @@
           <p:cNvPr id="6" name="Прямоугольник 5">
             <a:extLst>
               <a:ext uri="{FF2B5EF4-FFF2-40B4-BE49-F238E27FC236}">
-                <a16:creationId xmlns:a16="http://schemas.microsoft.com/office/drawing/2014/main" id="{4B009015-3481-72B7-C009-B95BD308F102}"/>
+                <a16:creationId xmlns:a16="http://schemas.microsoft.com/office/drawing/2014/main" id="{57977D09-AC97-EFB9-7EA2-7238283DFAD8}"/>
               </a:ext>
             </a:extLst>
           </p:cNvPr>
@@ -4905,7 +4905,7 @@
           <p:cNvPr id="7" name="TextBox 6">
             <a:extLst>
               <a:ext uri="{FF2B5EF4-FFF2-40B4-BE49-F238E27FC236}">
-                <a16:creationId xmlns:a16="http://schemas.microsoft.com/office/drawing/2014/main" id="{1BF1299B-192B-A78F-6AD6-16A70A6FD712}"/>
+                <a16:creationId xmlns:a16="http://schemas.microsoft.com/office/drawing/2014/main" id="{6802688B-87C3-238C-1C91-C59D23896CA6}"/>
               </a:ext>
             </a:extLst>
           </p:cNvPr>
@@ -4978,7 +4978,7 @@
           <p:cNvPr id="8" name="TextBox 7">
             <a:extLst>
               <a:ext uri="{FF2B5EF4-FFF2-40B4-BE49-F238E27FC236}">
-                <a16:creationId xmlns:a16="http://schemas.microsoft.com/office/drawing/2014/main" id="{774E1538-DD77-A6C7-B665-EA7E5EE59F2B}"/>
+                <a16:creationId xmlns:a16="http://schemas.microsoft.com/office/drawing/2014/main" id="{9C6256E4-44A6-FE50-C67B-107688A398C6}"/>
               </a:ext>
             </a:extLst>
           </p:cNvPr>
@@ -5049,7 +5049,7 @@
     </p:spTree>
     <p:extLst>
       <p:ext uri="{BB962C8B-B14F-4D97-AF65-F5344CB8AC3E}">
-        <p14:creationId xmlns:p14="http://schemas.microsoft.com/office/powerpoint/2010/main" val="100610520"/>
+        <p14:creationId xmlns:p14="http://schemas.microsoft.com/office/powerpoint/2010/main" val="4170689663"/>
       </p:ext>
     </p:extLst>
   </p:cSld>
@@ -5081,7 +5081,7 @@
           <p:cNvPr id="2" name="Прямоугольник 1">
             <a:extLst>
               <a:ext uri="{FF2B5EF4-FFF2-40B4-BE49-F238E27FC236}">
-                <a16:creationId xmlns:a16="http://schemas.microsoft.com/office/drawing/2014/main" id="{0753138C-698E-9BFF-96E4-7980AFCE3DCE}"/>
+                <a16:creationId xmlns:a16="http://schemas.microsoft.com/office/drawing/2014/main" id="{7D89CA07-C99A-982F-24ED-C22A7AD00AB4}"/>
               </a:ext>
             </a:extLst>
           </p:cNvPr>
@@ -5149,7 +5149,7 @@
           <p:cNvPr id="3" name="Прямоугольник 2">
             <a:extLst>
               <a:ext uri="{FF2B5EF4-FFF2-40B4-BE49-F238E27FC236}">
-                <a16:creationId xmlns:a16="http://schemas.microsoft.com/office/drawing/2014/main" id="{89C49059-D909-D7A2-60F6-3C354F1EACD2}"/>
+                <a16:creationId xmlns:a16="http://schemas.microsoft.com/office/drawing/2014/main" id="{371A4BBA-4248-0CBE-C6F4-13C58093E3B5}"/>
               </a:ext>
             </a:extLst>
           </p:cNvPr>
@@ -5217,7 +5217,7 @@
           <p:cNvPr id="4" name="TextBox 3">
             <a:extLst>
               <a:ext uri="{FF2B5EF4-FFF2-40B4-BE49-F238E27FC236}">
-                <a16:creationId xmlns:a16="http://schemas.microsoft.com/office/drawing/2014/main" id="{4E0D6651-8826-1F6F-0563-728906236CF1}"/>
+                <a16:creationId xmlns:a16="http://schemas.microsoft.com/office/drawing/2014/main" id="{2110E07B-B826-F0AF-88A5-F6C5B99CAA66}"/>
               </a:ext>
             </a:extLst>
           </p:cNvPr>
@@ -5257,7 +5257,7 @@
           <p:cNvPr id="5" name="TextBox 4">
             <a:extLst>
               <a:ext uri="{FF2B5EF4-FFF2-40B4-BE49-F238E27FC236}">
-                <a16:creationId xmlns:a16="http://schemas.microsoft.com/office/drawing/2014/main" id="{64BA278C-2263-CA39-2975-EA0809274A72}"/>
+                <a16:creationId xmlns:a16="http://schemas.microsoft.com/office/drawing/2014/main" id="{C3D15CAC-20D6-CF0F-6C03-4843055A840F}"/>
               </a:ext>
             </a:extLst>
           </p:cNvPr>
@@ -5298,7 +5298,7 @@
           <p:cNvPr id="6" name="Прямоугольник 5">
             <a:extLst>
               <a:ext uri="{FF2B5EF4-FFF2-40B4-BE49-F238E27FC236}">
-                <a16:creationId xmlns:a16="http://schemas.microsoft.com/office/drawing/2014/main" id="{B3942CF7-38AF-8D48-9B1C-DE497ED64E8B}"/>
+                <a16:creationId xmlns:a16="http://schemas.microsoft.com/office/drawing/2014/main" id="{EFB395B3-92CE-814B-6EFE-FE3CEFF8866B}"/>
               </a:ext>
             </a:extLst>
           </p:cNvPr>
@@ -5366,7 +5366,7 @@
           <p:cNvPr id="7" name="Прямоугольник 6">
             <a:extLst>
               <a:ext uri="{FF2B5EF4-FFF2-40B4-BE49-F238E27FC236}">
-                <a16:creationId xmlns:a16="http://schemas.microsoft.com/office/drawing/2014/main" id="{0FE4EE15-8005-A7ED-7F6F-D6E74134F8B7}"/>
+                <a16:creationId xmlns:a16="http://schemas.microsoft.com/office/drawing/2014/main" id="{E60CD6E7-25F2-B40D-796B-727226119D26}"/>
               </a:ext>
             </a:extLst>
           </p:cNvPr>
@@ -5434,7 +5434,7 @@
           <p:cNvPr id="9" name="Рисунок 8">
             <a:extLst>
               <a:ext uri="{FF2B5EF4-FFF2-40B4-BE49-F238E27FC236}">
-                <a16:creationId xmlns:a16="http://schemas.microsoft.com/office/drawing/2014/main" id="{878AABEC-BDDB-C8CF-A70B-6285362A785B}"/>
+                <a16:creationId xmlns:a16="http://schemas.microsoft.com/office/drawing/2014/main" id="{451EA827-46CA-C19F-C8EA-6E56983316D0}"/>
               </a:ext>
             </a:extLst>
           </p:cNvPr>
@@ -5470,7 +5470,7 @@
           <p:cNvPr id="10" name="TextBox 9">
             <a:extLst>
               <a:ext uri="{FF2B5EF4-FFF2-40B4-BE49-F238E27FC236}">
-                <a16:creationId xmlns:a16="http://schemas.microsoft.com/office/drawing/2014/main" id="{79C65D1E-D52F-EE34-B884-33BDEA9017E4}"/>
+                <a16:creationId xmlns:a16="http://schemas.microsoft.com/office/drawing/2014/main" id="{2042B211-622A-BE1A-184B-5A9F459E0BF9}"/>
               </a:ext>
             </a:extLst>
           </p:cNvPr>
@@ -5516,7 +5516,7 @@
           <p:cNvPr id="11" name="TextBox 10">
             <a:extLst>
               <a:ext uri="{FF2B5EF4-FFF2-40B4-BE49-F238E27FC236}">
-                <a16:creationId xmlns:a16="http://schemas.microsoft.com/office/drawing/2014/main" id="{C27BC766-877C-18D8-2CB7-030021396EF2}"/>
+                <a16:creationId xmlns:a16="http://schemas.microsoft.com/office/drawing/2014/main" id="{2E185420-278B-DAD1-D565-C90055ABF66F}"/>
               </a:ext>
             </a:extLst>
           </p:cNvPr>
@@ -5556,7 +5556,7 @@
           <p:cNvPr id="12" name="Прямоугольник 11">
             <a:extLst>
               <a:ext uri="{FF2B5EF4-FFF2-40B4-BE49-F238E27FC236}">
-                <a16:creationId xmlns:a16="http://schemas.microsoft.com/office/drawing/2014/main" id="{BDF55F21-87E9-2A20-D355-9FC68C656ED4}"/>
+                <a16:creationId xmlns:a16="http://schemas.microsoft.com/office/drawing/2014/main" id="{565654F6-098D-AEDE-E7BE-6458D5BE9540}"/>
               </a:ext>
             </a:extLst>
           </p:cNvPr>
@@ -5624,7 +5624,7 @@
           <p:cNvPr id="14" name="Рисунок 13">
             <a:extLst>
               <a:ext uri="{FF2B5EF4-FFF2-40B4-BE49-F238E27FC236}">
-                <a16:creationId xmlns:a16="http://schemas.microsoft.com/office/drawing/2014/main" id="{B96F7755-16A8-7257-F748-650C157A4022}"/>
+                <a16:creationId xmlns:a16="http://schemas.microsoft.com/office/drawing/2014/main" id="{B75AE2C5-2A04-77EA-FCFF-25BA1AFBFB29}"/>
               </a:ext>
             </a:extLst>
           </p:cNvPr>
@@ -5660,7 +5660,7 @@
           <p:cNvPr id="15" name="TextBox 14">
             <a:extLst>
               <a:ext uri="{FF2B5EF4-FFF2-40B4-BE49-F238E27FC236}">
-                <a16:creationId xmlns:a16="http://schemas.microsoft.com/office/drawing/2014/main" id="{03F29623-6D66-B084-1A8B-06841BF6DA7E}"/>
+                <a16:creationId xmlns:a16="http://schemas.microsoft.com/office/drawing/2014/main" id="{8956D0FA-62A9-1393-7E4B-18B6B7FB315F}"/>
               </a:ext>
             </a:extLst>
           </p:cNvPr>
@@ -5706,7 +5706,7 @@
           <p:cNvPr id="16" name="TextBox 15">
             <a:extLst>
               <a:ext uri="{FF2B5EF4-FFF2-40B4-BE49-F238E27FC236}">
-                <a16:creationId xmlns:a16="http://schemas.microsoft.com/office/drawing/2014/main" id="{16D616B4-D562-04C7-7812-D8B395E0263A}"/>
+                <a16:creationId xmlns:a16="http://schemas.microsoft.com/office/drawing/2014/main" id="{EE00D510-CC7E-6DB9-734E-57764A55C81B}"/>
               </a:ext>
             </a:extLst>
           </p:cNvPr>
@@ -5746,7 +5746,7 @@
           <p:cNvPr id="17" name="Прямоугольник 16">
             <a:extLst>
               <a:ext uri="{FF2B5EF4-FFF2-40B4-BE49-F238E27FC236}">
-                <a16:creationId xmlns:a16="http://schemas.microsoft.com/office/drawing/2014/main" id="{367B6A2D-4E6C-6DB6-E741-7D69BC0820D8}"/>
+                <a16:creationId xmlns:a16="http://schemas.microsoft.com/office/drawing/2014/main" id="{BA2309D4-299C-86F1-B35F-0BAA4B67536E}"/>
               </a:ext>
             </a:extLst>
           </p:cNvPr>
@@ -5814,7 +5814,7 @@
           <p:cNvPr id="19" name="Рисунок 18">
             <a:extLst>
               <a:ext uri="{FF2B5EF4-FFF2-40B4-BE49-F238E27FC236}">
-                <a16:creationId xmlns:a16="http://schemas.microsoft.com/office/drawing/2014/main" id="{132708FA-7870-707A-2C3A-976616198C2E}"/>
+                <a16:creationId xmlns:a16="http://schemas.microsoft.com/office/drawing/2014/main" id="{EE6AEE6B-2B76-6935-5EFB-1FDE267CA5A5}"/>
               </a:ext>
             </a:extLst>
           </p:cNvPr>
@@ -5850,7 +5850,7 @@
           <p:cNvPr id="20" name="TextBox 19">
             <a:extLst>
               <a:ext uri="{FF2B5EF4-FFF2-40B4-BE49-F238E27FC236}">
-                <a16:creationId xmlns:a16="http://schemas.microsoft.com/office/drawing/2014/main" id="{51C17223-5F60-4AB8-37A2-290267141E66}"/>
+                <a16:creationId xmlns:a16="http://schemas.microsoft.com/office/drawing/2014/main" id="{8B9C8511-C681-BD13-F13F-BD5417B4A44F}"/>
               </a:ext>
             </a:extLst>
           </p:cNvPr>
@@ -5896,7 +5896,7 @@
           <p:cNvPr id="21" name="TextBox 20">
             <a:extLst>
               <a:ext uri="{FF2B5EF4-FFF2-40B4-BE49-F238E27FC236}">
-                <a16:creationId xmlns:a16="http://schemas.microsoft.com/office/drawing/2014/main" id="{8BADAC95-9B50-DCAF-A06E-C8597B31B941}"/>
+                <a16:creationId xmlns:a16="http://schemas.microsoft.com/office/drawing/2014/main" id="{818D66F2-7649-E214-8E42-80EBB4427E83}"/>
               </a:ext>
             </a:extLst>
           </p:cNvPr>
@@ -5936,7 +5936,7 @@
           <p:cNvPr id="22" name="Прямоугольник 21">
             <a:extLst>
               <a:ext uri="{FF2B5EF4-FFF2-40B4-BE49-F238E27FC236}">
-                <a16:creationId xmlns:a16="http://schemas.microsoft.com/office/drawing/2014/main" id="{2B623851-DE49-D702-408E-1612DA3E5D08}"/>
+                <a16:creationId xmlns:a16="http://schemas.microsoft.com/office/drawing/2014/main" id="{A09500E5-3625-14E4-54C9-B3384FDE0437}"/>
               </a:ext>
             </a:extLst>
           </p:cNvPr>
@@ -6004,7 +6004,7 @@
           <p:cNvPr id="24" name="Рисунок 23">
             <a:extLst>
               <a:ext uri="{FF2B5EF4-FFF2-40B4-BE49-F238E27FC236}">
-                <a16:creationId xmlns:a16="http://schemas.microsoft.com/office/drawing/2014/main" id="{F8B76B9C-66C6-4DBF-AF44-95130DF57225}"/>
+                <a16:creationId xmlns:a16="http://schemas.microsoft.com/office/drawing/2014/main" id="{70F4EE56-F556-01B3-A2FC-3A18E00B17B4}"/>
               </a:ext>
             </a:extLst>
           </p:cNvPr>
@@ -6040,7 +6040,7 @@
           <p:cNvPr id="25" name="TextBox 24">
             <a:extLst>
               <a:ext uri="{FF2B5EF4-FFF2-40B4-BE49-F238E27FC236}">
-                <a16:creationId xmlns:a16="http://schemas.microsoft.com/office/drawing/2014/main" id="{900C2E7F-9AF7-92EB-7671-EEA2AEB86A5B}"/>
+                <a16:creationId xmlns:a16="http://schemas.microsoft.com/office/drawing/2014/main" id="{5E249E43-6F0F-BBEE-3305-FC2A76C6B4DF}"/>
               </a:ext>
             </a:extLst>
           </p:cNvPr>
@@ -6089,7 +6089,7 @@
           <p:cNvPr id="26" name="TextBox 25">
             <a:extLst>
               <a:ext uri="{FF2B5EF4-FFF2-40B4-BE49-F238E27FC236}">
-                <a16:creationId xmlns:a16="http://schemas.microsoft.com/office/drawing/2014/main" id="{185A0B60-BC31-FA69-E649-89F8B8B2CC05}"/>
+                <a16:creationId xmlns:a16="http://schemas.microsoft.com/office/drawing/2014/main" id="{9A5F0215-9DD3-4622-F4F4-8CF208D1A000}"/>
               </a:ext>
             </a:extLst>
           </p:cNvPr>
@@ -6129,7 +6129,7 @@
           <p:cNvPr id="27" name="TextBox 26">
             <a:extLst>
               <a:ext uri="{FF2B5EF4-FFF2-40B4-BE49-F238E27FC236}">
-                <a16:creationId xmlns:a16="http://schemas.microsoft.com/office/drawing/2014/main" id="{1E86A962-5F8B-46DD-129C-91CE6BDACE22}"/>
+                <a16:creationId xmlns:a16="http://schemas.microsoft.com/office/drawing/2014/main" id="{201FC0D9-B946-1C0A-20DD-9E9D68763EA3}"/>
               </a:ext>
             </a:extLst>
           </p:cNvPr>
@@ -6167,7 +6167,7 @@
     </p:spTree>
     <p:extLst>
       <p:ext uri="{BB962C8B-B14F-4D97-AF65-F5344CB8AC3E}">
-        <p14:creationId xmlns:p14="http://schemas.microsoft.com/office/powerpoint/2010/main" val="1187088944"/>
+        <p14:creationId xmlns:p14="http://schemas.microsoft.com/office/powerpoint/2010/main" val="1370688197"/>
       </p:ext>
     </p:extLst>
   </p:cSld>
@@ -6199,7 +6199,7 @@
           <p:cNvPr id="2" name="Прямоугольник 1">
             <a:extLst>
               <a:ext uri="{FF2B5EF4-FFF2-40B4-BE49-F238E27FC236}">
-                <a16:creationId xmlns:a16="http://schemas.microsoft.com/office/drawing/2014/main" id="{37D31D25-5C6B-C055-9151-C4DD20D8C195}"/>
+                <a16:creationId xmlns:a16="http://schemas.microsoft.com/office/drawing/2014/main" id="{F36F3507-77F6-6BB4-4D78-B341E54CC4CE}"/>
               </a:ext>
             </a:extLst>
           </p:cNvPr>
@@ -6267,7 +6267,7 @@
           <p:cNvPr id="3" name="Прямоугольник 2">
             <a:extLst>
               <a:ext uri="{FF2B5EF4-FFF2-40B4-BE49-F238E27FC236}">
-                <a16:creationId xmlns:a16="http://schemas.microsoft.com/office/drawing/2014/main" id="{1916D216-D78A-B526-90EB-3A7B1D0894B6}"/>
+                <a16:creationId xmlns:a16="http://schemas.microsoft.com/office/drawing/2014/main" id="{A72C0A50-6A65-2B16-5B85-5C08602B4833}"/>
               </a:ext>
             </a:extLst>
           </p:cNvPr>
@@ -6335,7 +6335,7 @@
           <p:cNvPr id="4" name="TextBox 3">
             <a:extLst>
               <a:ext uri="{FF2B5EF4-FFF2-40B4-BE49-F238E27FC236}">
-                <a16:creationId xmlns:a16="http://schemas.microsoft.com/office/drawing/2014/main" id="{2522945F-CF6D-31AB-0174-EF1200F62905}"/>
+                <a16:creationId xmlns:a16="http://schemas.microsoft.com/office/drawing/2014/main" id="{8C774E66-9F1E-4550-0CBB-D192F0493AD9}"/>
               </a:ext>
             </a:extLst>
           </p:cNvPr>
@@ -6375,7 +6375,7 @@
           <p:cNvPr id="5" name="TextBox 4">
             <a:extLst>
               <a:ext uri="{FF2B5EF4-FFF2-40B4-BE49-F238E27FC236}">
-                <a16:creationId xmlns:a16="http://schemas.microsoft.com/office/drawing/2014/main" id="{4BA56B81-5F57-C1A3-E116-FEC00044B112}"/>
+                <a16:creationId xmlns:a16="http://schemas.microsoft.com/office/drawing/2014/main" id="{15CCC135-0A46-68D5-5DB4-A997E321D843}"/>
               </a:ext>
             </a:extLst>
           </p:cNvPr>
@@ -6416,7 +6416,7 @@
           <p:cNvPr id="6" name="Прямоугольник 5">
             <a:extLst>
               <a:ext uri="{FF2B5EF4-FFF2-40B4-BE49-F238E27FC236}">
-                <a16:creationId xmlns:a16="http://schemas.microsoft.com/office/drawing/2014/main" id="{D81B62E3-F090-2355-65A4-13C697582E7A}"/>
+                <a16:creationId xmlns:a16="http://schemas.microsoft.com/office/drawing/2014/main" id="{1DEF9699-DBEA-A8F9-42EE-B3A436A42460}"/>
               </a:ext>
             </a:extLst>
           </p:cNvPr>
@@ -6484,7 +6484,7 @@
           <p:cNvPr id="8" name="Рисунок 7">
             <a:extLst>
               <a:ext uri="{FF2B5EF4-FFF2-40B4-BE49-F238E27FC236}">
-                <a16:creationId xmlns:a16="http://schemas.microsoft.com/office/drawing/2014/main" id="{0D0FB8F3-A7FD-2685-3613-B3E81EA5FAB8}"/>
+                <a16:creationId xmlns:a16="http://schemas.microsoft.com/office/drawing/2014/main" id="{27AE21FE-8002-5DAB-7CF4-E22257D6FEE5}"/>
               </a:ext>
             </a:extLst>
           </p:cNvPr>
@@ -6520,7 +6520,7 @@
           <p:cNvPr id="9" name="TextBox 8">
             <a:extLst>
               <a:ext uri="{FF2B5EF4-FFF2-40B4-BE49-F238E27FC236}">
-                <a16:creationId xmlns:a16="http://schemas.microsoft.com/office/drawing/2014/main" id="{07C1047E-F1E1-A6DF-EE79-E7FE892F3310}"/>
+                <a16:creationId xmlns:a16="http://schemas.microsoft.com/office/drawing/2014/main" id="{FB4E074C-819E-BD84-38B2-2138A28C09E1}"/>
               </a:ext>
             </a:extLst>
           </p:cNvPr>
@@ -6639,7 +6639,7 @@
     </p:spTree>
     <p:extLst>
       <p:ext uri="{BB962C8B-B14F-4D97-AF65-F5344CB8AC3E}">
-        <p14:creationId xmlns:p14="http://schemas.microsoft.com/office/powerpoint/2010/main" val="1659144880"/>
+        <p14:creationId xmlns:p14="http://schemas.microsoft.com/office/powerpoint/2010/main" val="4178676166"/>
       </p:ext>
     </p:extLst>
   </p:cSld>
@@ -6671,7 +6671,7 @@
           <p:cNvPr id="2" name="Прямоугольник 1">
             <a:extLst>
               <a:ext uri="{FF2B5EF4-FFF2-40B4-BE49-F238E27FC236}">
-                <a16:creationId xmlns:a16="http://schemas.microsoft.com/office/drawing/2014/main" id="{2F101817-44C6-27C5-347F-A5834E5E07F2}"/>
+                <a16:creationId xmlns:a16="http://schemas.microsoft.com/office/drawing/2014/main" id="{5A0A09D0-7DD7-C930-6026-16C4E1A845EA}"/>
               </a:ext>
             </a:extLst>
           </p:cNvPr>
@@ -6739,7 +6739,7 @@
           <p:cNvPr id="3" name="Прямоугольник 2">
             <a:extLst>
               <a:ext uri="{FF2B5EF4-FFF2-40B4-BE49-F238E27FC236}">
-                <a16:creationId xmlns:a16="http://schemas.microsoft.com/office/drawing/2014/main" id="{562C7E9A-2B26-FCA9-90E3-1644247A20E8}"/>
+                <a16:creationId xmlns:a16="http://schemas.microsoft.com/office/drawing/2014/main" id="{378F1F24-7D81-29E8-D6E7-5B8EFD16FA12}"/>
               </a:ext>
             </a:extLst>
           </p:cNvPr>
@@ -6807,7 +6807,7 @@
           <p:cNvPr id="4" name="TextBox 3">
             <a:extLst>
               <a:ext uri="{FF2B5EF4-FFF2-40B4-BE49-F238E27FC236}">
-                <a16:creationId xmlns:a16="http://schemas.microsoft.com/office/drawing/2014/main" id="{E809EBCF-D491-2346-45B7-0505AA3A2A9E}"/>
+                <a16:creationId xmlns:a16="http://schemas.microsoft.com/office/drawing/2014/main" id="{31BB247C-4DB9-B26B-E398-F671345B6ACB}"/>
               </a:ext>
             </a:extLst>
           </p:cNvPr>
@@ -6847,7 +6847,7 @@
           <p:cNvPr id="5" name="TextBox 4">
             <a:extLst>
               <a:ext uri="{FF2B5EF4-FFF2-40B4-BE49-F238E27FC236}">
-                <a16:creationId xmlns:a16="http://schemas.microsoft.com/office/drawing/2014/main" id="{5371A475-52F3-7938-D909-836BD1C59165}"/>
+                <a16:creationId xmlns:a16="http://schemas.microsoft.com/office/drawing/2014/main" id="{5164F03F-7EE9-F6FC-2225-F50EFE0E4FFB}"/>
               </a:ext>
             </a:extLst>
           </p:cNvPr>
@@ -6888,7 +6888,7 @@
           <p:cNvPr id="6" name="Прямоугольник 5">
             <a:extLst>
               <a:ext uri="{FF2B5EF4-FFF2-40B4-BE49-F238E27FC236}">
-                <a16:creationId xmlns:a16="http://schemas.microsoft.com/office/drawing/2014/main" id="{981AB3C2-8B88-064C-5B28-9EBEAFE2B8B1}"/>
+                <a16:creationId xmlns:a16="http://schemas.microsoft.com/office/drawing/2014/main" id="{9E0CEA50-CCB1-E4D6-0204-1EC348BC9CB8}"/>
               </a:ext>
             </a:extLst>
           </p:cNvPr>
@@ -6956,7 +6956,7 @@
           <p:cNvPr id="7" name="Таблица 6">
             <a:extLst>
               <a:ext uri="{FF2B5EF4-FFF2-40B4-BE49-F238E27FC236}">
-                <a16:creationId xmlns:a16="http://schemas.microsoft.com/office/drawing/2014/main" id="{67749A7B-6EF5-C7BE-53E9-6A71585B6348}"/>
+                <a16:creationId xmlns:a16="http://schemas.microsoft.com/office/drawing/2014/main" id="{111921A2-27CA-7244-35FF-80CE08852346}"/>
               </a:ext>
             </a:extLst>
           </p:cNvPr>
@@ -6966,7 +6966,7 @@
           <p:nvPr>
             <p:extLst>
               <p:ext uri="{D42A27DB-BD31-4B8C-83A1-F6EECF244321}">
-                <p14:modId xmlns:p14="http://schemas.microsoft.com/office/powerpoint/2010/main" val="1917887351"/>
+                <p14:modId xmlns:p14="http://schemas.microsoft.com/office/powerpoint/2010/main" val="928112676"/>
               </p:ext>
             </p:extLst>
           </p:nvPr>
@@ -6985,21 +6985,21 @@
                 <a:gridCol w="2413000">
                   <a:extLst>
                     <a:ext uri="{9D8B030D-6E8A-4147-A177-3AD203B41FA5}">
-                      <a16:colId xmlns:a16="http://schemas.microsoft.com/office/drawing/2014/main" val="1323644642"/>
+                      <a16:colId xmlns:a16="http://schemas.microsoft.com/office/drawing/2014/main" val="2886896077"/>
                     </a:ext>
                   </a:extLst>
                 </a:gridCol>
                 <a:gridCol w="5969000">
                   <a:extLst>
                     <a:ext uri="{9D8B030D-6E8A-4147-A177-3AD203B41FA5}">
-                      <a16:colId xmlns:a16="http://schemas.microsoft.com/office/drawing/2014/main" val="1320674707"/>
+                      <a16:colId xmlns:a16="http://schemas.microsoft.com/office/drawing/2014/main" val="1090525714"/>
                     </a:ext>
                   </a:extLst>
                 </a:gridCol>
                 <a:gridCol w="2692400">
                   <a:extLst>
                     <a:ext uri="{9D8B030D-6E8A-4147-A177-3AD203B41FA5}">
-                      <a16:colId xmlns:a16="http://schemas.microsoft.com/office/drawing/2014/main" val="467198074"/>
+                      <a16:colId xmlns:a16="http://schemas.microsoft.com/office/drawing/2014/main" val="4237194425"/>
                     </a:ext>
                   </a:extLst>
                 </a:gridCol>
@@ -7073,7 +7073,7 @@
                 </a:tc>
                 <a:extLst>
                   <a:ext uri="{0D108BD9-81ED-4DB2-BD59-A6C34878D82A}">
-                    <a16:rowId xmlns:a16="http://schemas.microsoft.com/office/drawing/2014/main" val="132676859"/>
+                    <a16:rowId xmlns:a16="http://schemas.microsoft.com/office/drawing/2014/main" val="1198988284"/>
                   </a:ext>
                 </a:extLst>
               </a:tr>
@@ -7146,7 +7146,7 @@
                 </a:tc>
                 <a:extLst>
                   <a:ext uri="{0D108BD9-81ED-4DB2-BD59-A6C34878D82A}">
-                    <a16:rowId xmlns:a16="http://schemas.microsoft.com/office/drawing/2014/main" val="3617640360"/>
+                    <a16:rowId xmlns:a16="http://schemas.microsoft.com/office/drawing/2014/main" val="1271698673"/>
                   </a:ext>
                 </a:extLst>
               </a:tr>
@@ -7219,7 +7219,7 @@
                 </a:tc>
                 <a:extLst>
                   <a:ext uri="{0D108BD9-81ED-4DB2-BD59-A6C34878D82A}">
-                    <a16:rowId xmlns:a16="http://schemas.microsoft.com/office/drawing/2014/main" val="1365727369"/>
+                    <a16:rowId xmlns:a16="http://schemas.microsoft.com/office/drawing/2014/main" val="3322552516"/>
                   </a:ext>
                 </a:extLst>
               </a:tr>
@@ -7292,7 +7292,7 @@
                 </a:tc>
                 <a:extLst>
                   <a:ext uri="{0D108BD9-81ED-4DB2-BD59-A6C34878D82A}">
-                    <a16:rowId xmlns:a16="http://schemas.microsoft.com/office/drawing/2014/main" val="2597194343"/>
+                    <a16:rowId xmlns:a16="http://schemas.microsoft.com/office/drawing/2014/main" val="2788340979"/>
                   </a:ext>
                 </a:extLst>
               </a:tr>
@@ -7305,7 +7305,7 @@
           <p:cNvPr id="8" name="TextBox 7">
             <a:extLst>
               <a:ext uri="{FF2B5EF4-FFF2-40B4-BE49-F238E27FC236}">
-                <a16:creationId xmlns:a16="http://schemas.microsoft.com/office/drawing/2014/main" id="{CDE860AB-7232-0EBB-0B9F-02654D9952B5}"/>
+                <a16:creationId xmlns:a16="http://schemas.microsoft.com/office/drawing/2014/main" id="{46FFABBC-FD9C-31C7-7B30-5AE68C428F8F}"/>
               </a:ext>
             </a:extLst>
           </p:cNvPr>
@@ -7343,7 +7343,7 @@
     </p:spTree>
     <p:extLst>
       <p:ext uri="{BB962C8B-B14F-4D97-AF65-F5344CB8AC3E}">
-        <p14:creationId xmlns:p14="http://schemas.microsoft.com/office/powerpoint/2010/main" val="838911884"/>
+        <p14:creationId xmlns:p14="http://schemas.microsoft.com/office/powerpoint/2010/main" val="3085278276"/>
       </p:ext>
     </p:extLst>
   </p:cSld>
@@ -7375,7 +7375,7 @@
           <p:cNvPr id="2" name="Прямоугольник 1">
             <a:extLst>
               <a:ext uri="{FF2B5EF4-FFF2-40B4-BE49-F238E27FC236}">
-                <a16:creationId xmlns:a16="http://schemas.microsoft.com/office/drawing/2014/main" id="{ADC9E1D5-93FA-DDDE-AFD2-E7329CE8B8F7}"/>
+                <a16:creationId xmlns:a16="http://schemas.microsoft.com/office/drawing/2014/main" id="{13E7BF4A-A64A-C762-7F60-C45903C9D3B0}"/>
               </a:ext>
             </a:extLst>
           </p:cNvPr>
@@ -7443,7 +7443,7 @@
           <p:cNvPr id="3" name="Прямоугольник 2">
             <a:extLst>
               <a:ext uri="{FF2B5EF4-FFF2-40B4-BE49-F238E27FC236}">
-                <a16:creationId xmlns:a16="http://schemas.microsoft.com/office/drawing/2014/main" id="{016D51FE-EBEC-E10C-0AD5-35363A3D9107}"/>
+                <a16:creationId xmlns:a16="http://schemas.microsoft.com/office/drawing/2014/main" id="{EE9E813F-89AF-E823-49EA-1BFE4A95FE7C}"/>
               </a:ext>
             </a:extLst>
           </p:cNvPr>
@@ -7511,7 +7511,7 @@
           <p:cNvPr id="4" name="TextBox 3">
             <a:extLst>
               <a:ext uri="{FF2B5EF4-FFF2-40B4-BE49-F238E27FC236}">
-                <a16:creationId xmlns:a16="http://schemas.microsoft.com/office/drawing/2014/main" id="{0B33F817-570F-275A-8A18-D6A386DBFD80}"/>
+                <a16:creationId xmlns:a16="http://schemas.microsoft.com/office/drawing/2014/main" id="{97556D7E-E34A-35BD-6EDC-23D1471E7B51}"/>
               </a:ext>
             </a:extLst>
           </p:cNvPr>
@@ -7551,7 +7551,7 @@
           <p:cNvPr id="5" name="TextBox 4">
             <a:extLst>
               <a:ext uri="{FF2B5EF4-FFF2-40B4-BE49-F238E27FC236}">
-                <a16:creationId xmlns:a16="http://schemas.microsoft.com/office/drawing/2014/main" id="{481FC03C-C69A-D11E-FA91-7BDA628D34AB}"/>
+                <a16:creationId xmlns:a16="http://schemas.microsoft.com/office/drawing/2014/main" id="{B861FAA2-CBFE-BD14-A703-850ADF859146}"/>
               </a:ext>
             </a:extLst>
           </p:cNvPr>
@@ -7592,7 +7592,7 @@
           <p:cNvPr id="6" name="Прямоугольник 5">
             <a:extLst>
               <a:ext uri="{FF2B5EF4-FFF2-40B4-BE49-F238E27FC236}">
-                <a16:creationId xmlns:a16="http://schemas.microsoft.com/office/drawing/2014/main" id="{5329FDC0-1EBC-BE14-28BE-646E3A1086B2}"/>
+                <a16:creationId xmlns:a16="http://schemas.microsoft.com/office/drawing/2014/main" id="{276C1427-D4FA-EBA6-D372-D5B536BE52C6}"/>
               </a:ext>
             </a:extLst>
           </p:cNvPr>
@@ -7660,7 +7660,7 @@
           <p:cNvPr id="7" name="Прямоугольник 6">
             <a:extLst>
               <a:ext uri="{FF2B5EF4-FFF2-40B4-BE49-F238E27FC236}">
-                <a16:creationId xmlns:a16="http://schemas.microsoft.com/office/drawing/2014/main" id="{D006D3FB-9FE2-6077-84FD-D92A70DC9D5C}"/>
+                <a16:creationId xmlns:a16="http://schemas.microsoft.com/office/drawing/2014/main" id="{6DBCF616-B0ED-BF56-E00C-80E31C222653}"/>
               </a:ext>
             </a:extLst>
           </p:cNvPr>
@@ -7728,7 +7728,7 @@
           <p:cNvPr id="8" name="Прямоугольник 7">
             <a:extLst>
               <a:ext uri="{FF2B5EF4-FFF2-40B4-BE49-F238E27FC236}">
-                <a16:creationId xmlns:a16="http://schemas.microsoft.com/office/drawing/2014/main" id="{5483E6A9-54E7-077D-4B39-249FB292601E}"/>
+                <a16:creationId xmlns:a16="http://schemas.microsoft.com/office/drawing/2014/main" id="{7859A928-79E2-CEDA-050C-309F16AB6501}"/>
               </a:ext>
             </a:extLst>
           </p:cNvPr>
@@ -7796,7 +7796,7 @@
           <p:cNvPr id="9" name="TextBox 8">
             <a:extLst>
               <a:ext uri="{FF2B5EF4-FFF2-40B4-BE49-F238E27FC236}">
-                <a16:creationId xmlns:a16="http://schemas.microsoft.com/office/drawing/2014/main" id="{B7A4A93B-5D5A-2630-2793-FE98EAA80D57}"/>
+                <a16:creationId xmlns:a16="http://schemas.microsoft.com/office/drawing/2014/main" id="{C3854BE8-F53F-EC48-3427-8C92CD34EE6B}"/>
               </a:ext>
             </a:extLst>
           </p:cNvPr>
@@ -7842,7 +7842,7 @@
           <p:cNvPr id="10" name="TextBox 9">
             <a:extLst>
               <a:ext uri="{FF2B5EF4-FFF2-40B4-BE49-F238E27FC236}">
-                <a16:creationId xmlns:a16="http://schemas.microsoft.com/office/drawing/2014/main" id="{DF8FEE0C-81B9-6030-1D06-D55A7A1AFB29}"/>
+                <a16:creationId xmlns:a16="http://schemas.microsoft.com/office/drawing/2014/main" id="{B3A3A77A-CA7D-1A49-72BF-87CF3D9291A1}"/>
               </a:ext>
             </a:extLst>
           </p:cNvPr>
@@ -7882,7 +7882,7 @@
           <p:cNvPr id="11" name="Прямоугольник 10">
             <a:extLst>
               <a:ext uri="{FF2B5EF4-FFF2-40B4-BE49-F238E27FC236}">
-                <a16:creationId xmlns:a16="http://schemas.microsoft.com/office/drawing/2014/main" id="{6EF22FC9-ECB1-7837-93E1-7F416F869FD5}"/>
+                <a16:creationId xmlns:a16="http://schemas.microsoft.com/office/drawing/2014/main" id="{4A7DFDF1-4EEC-4A56-9CCA-5007FD1BB129}"/>
               </a:ext>
             </a:extLst>
           </p:cNvPr>
@@ -7950,7 +7950,7 @@
           <p:cNvPr id="12" name="Прямоугольник 11">
             <a:extLst>
               <a:ext uri="{FF2B5EF4-FFF2-40B4-BE49-F238E27FC236}">
-                <a16:creationId xmlns:a16="http://schemas.microsoft.com/office/drawing/2014/main" id="{A44CF674-10E6-E102-7F8A-9A449FCAFC0D}"/>
+                <a16:creationId xmlns:a16="http://schemas.microsoft.com/office/drawing/2014/main" id="{F3929414-E7AC-9F72-A788-F978B4C1CA6D}"/>
               </a:ext>
             </a:extLst>
           </p:cNvPr>
@@ -8018,7 +8018,7 @@
           <p:cNvPr id="13" name="TextBox 12">
             <a:extLst>
               <a:ext uri="{FF2B5EF4-FFF2-40B4-BE49-F238E27FC236}">
-                <a16:creationId xmlns:a16="http://schemas.microsoft.com/office/drawing/2014/main" id="{E35B1F79-343A-3620-57CE-53AE99692AF0}"/>
+                <a16:creationId xmlns:a16="http://schemas.microsoft.com/office/drawing/2014/main" id="{88FF5D7B-5A28-959E-5504-48973260D89C}"/>
               </a:ext>
             </a:extLst>
           </p:cNvPr>
@@ -8064,7 +8064,7 @@
           <p:cNvPr id="14" name="TextBox 13">
             <a:extLst>
               <a:ext uri="{FF2B5EF4-FFF2-40B4-BE49-F238E27FC236}">
-                <a16:creationId xmlns:a16="http://schemas.microsoft.com/office/drawing/2014/main" id="{B2E93D89-4133-1FE0-D82C-2E6A0BDF427C}"/>
+                <a16:creationId xmlns:a16="http://schemas.microsoft.com/office/drawing/2014/main" id="{C6BE39A3-B44F-2212-7566-2FBDD25AD764}"/>
               </a:ext>
             </a:extLst>
           </p:cNvPr>
@@ -8104,7 +8104,7 @@
           <p:cNvPr id="15" name="Прямоугольник 14">
             <a:extLst>
               <a:ext uri="{FF2B5EF4-FFF2-40B4-BE49-F238E27FC236}">
-                <a16:creationId xmlns:a16="http://schemas.microsoft.com/office/drawing/2014/main" id="{A610AF79-8331-900E-3F9E-20129B050AE2}"/>
+                <a16:creationId xmlns:a16="http://schemas.microsoft.com/office/drawing/2014/main" id="{BAFC55E1-8A79-A098-7A66-E176613A55ED}"/>
               </a:ext>
             </a:extLst>
           </p:cNvPr>
@@ -8172,7 +8172,7 @@
           <p:cNvPr id="16" name="Прямоугольник 15">
             <a:extLst>
               <a:ext uri="{FF2B5EF4-FFF2-40B4-BE49-F238E27FC236}">
-                <a16:creationId xmlns:a16="http://schemas.microsoft.com/office/drawing/2014/main" id="{B10A24EB-710C-8E14-F610-58767597B57C}"/>
+                <a16:creationId xmlns:a16="http://schemas.microsoft.com/office/drawing/2014/main" id="{588C854E-6AD4-5813-267D-4AB7F4C6DDD2}"/>
               </a:ext>
             </a:extLst>
           </p:cNvPr>
@@ -8240,7 +8240,7 @@
           <p:cNvPr id="17" name="TextBox 16">
             <a:extLst>
               <a:ext uri="{FF2B5EF4-FFF2-40B4-BE49-F238E27FC236}">
-                <a16:creationId xmlns:a16="http://schemas.microsoft.com/office/drawing/2014/main" id="{74A30E87-0851-591A-52EF-0B28D0C21307}"/>
+                <a16:creationId xmlns:a16="http://schemas.microsoft.com/office/drawing/2014/main" id="{FB4767BF-9AD5-CD8F-02FA-F2774D0B8517}"/>
               </a:ext>
             </a:extLst>
           </p:cNvPr>
@@ -8286,7 +8286,7 @@
           <p:cNvPr id="18" name="TextBox 17">
             <a:extLst>
               <a:ext uri="{FF2B5EF4-FFF2-40B4-BE49-F238E27FC236}">
-                <a16:creationId xmlns:a16="http://schemas.microsoft.com/office/drawing/2014/main" id="{07C1305E-F97A-24D0-744E-D8263EAAA308}"/>
+                <a16:creationId xmlns:a16="http://schemas.microsoft.com/office/drawing/2014/main" id="{68BEFFCA-9747-B610-765B-912CB77D40CA}"/>
               </a:ext>
             </a:extLst>
           </p:cNvPr>
@@ -8326,7 +8326,7 @@
           <p:cNvPr id="19" name="Прямоугольник 18">
             <a:extLst>
               <a:ext uri="{FF2B5EF4-FFF2-40B4-BE49-F238E27FC236}">
-                <a16:creationId xmlns:a16="http://schemas.microsoft.com/office/drawing/2014/main" id="{CE8AFA7C-43FF-B350-930D-A97CC00D3E12}"/>
+                <a16:creationId xmlns:a16="http://schemas.microsoft.com/office/drawing/2014/main" id="{8FEF1AF6-C01E-C5F3-6316-AC31391EC2F5}"/>
               </a:ext>
             </a:extLst>
           </p:cNvPr>
@@ -8394,7 +8394,7 @@
           <p:cNvPr id="20" name="Прямоугольник 19">
             <a:extLst>
               <a:ext uri="{FF2B5EF4-FFF2-40B4-BE49-F238E27FC236}">
-                <a16:creationId xmlns:a16="http://schemas.microsoft.com/office/drawing/2014/main" id="{5E98C063-3CF4-EE53-7225-D5DC267C418E}"/>
+                <a16:creationId xmlns:a16="http://schemas.microsoft.com/office/drawing/2014/main" id="{D3E535C2-610B-444F-D9E5-E2723BC15E4D}"/>
               </a:ext>
             </a:extLst>
           </p:cNvPr>
@@ -8462,7 +8462,7 @@
           <p:cNvPr id="21" name="TextBox 20">
             <a:extLst>
               <a:ext uri="{FF2B5EF4-FFF2-40B4-BE49-F238E27FC236}">
-                <a16:creationId xmlns:a16="http://schemas.microsoft.com/office/drawing/2014/main" id="{FFD65B69-B40E-5534-2DAC-DD35B82A57BE}"/>
+                <a16:creationId xmlns:a16="http://schemas.microsoft.com/office/drawing/2014/main" id="{86E0F5D8-CB79-A6B1-D7EB-D05C3E2A54D0}"/>
               </a:ext>
             </a:extLst>
           </p:cNvPr>
@@ -8508,7 +8508,7 @@
           <p:cNvPr id="22" name="TextBox 21">
             <a:extLst>
               <a:ext uri="{FF2B5EF4-FFF2-40B4-BE49-F238E27FC236}">
-                <a16:creationId xmlns:a16="http://schemas.microsoft.com/office/drawing/2014/main" id="{F821F132-8EFA-2BB6-4219-612CA2ABB6FB}"/>
+                <a16:creationId xmlns:a16="http://schemas.microsoft.com/office/drawing/2014/main" id="{455DBB10-38F1-2223-BA62-575BFCE4D869}"/>
               </a:ext>
             </a:extLst>
           </p:cNvPr>
@@ -8548,7 +8548,7 @@
           <p:cNvPr id="23" name="Прямоугольник 22">
             <a:extLst>
               <a:ext uri="{FF2B5EF4-FFF2-40B4-BE49-F238E27FC236}">
-                <a16:creationId xmlns:a16="http://schemas.microsoft.com/office/drawing/2014/main" id="{3D175182-7D39-02BB-B8FC-43867E2E9C76}"/>
+                <a16:creationId xmlns:a16="http://schemas.microsoft.com/office/drawing/2014/main" id="{CD924D0F-378F-25CA-9A33-8011781E6A15}"/>
               </a:ext>
             </a:extLst>
           </p:cNvPr>
@@ -8616,7 +8616,7 @@
           <p:cNvPr id="24" name="Прямоугольник 23">
             <a:extLst>
               <a:ext uri="{FF2B5EF4-FFF2-40B4-BE49-F238E27FC236}">
-                <a16:creationId xmlns:a16="http://schemas.microsoft.com/office/drawing/2014/main" id="{345E5D4D-04D4-6877-2E34-1104278D06B5}"/>
+                <a16:creationId xmlns:a16="http://schemas.microsoft.com/office/drawing/2014/main" id="{8894C5CD-64AC-9ECF-44C5-7FE7E88A825B}"/>
               </a:ext>
             </a:extLst>
           </p:cNvPr>
@@ -8684,7 +8684,7 @@
           <p:cNvPr id="25" name="TextBox 24">
             <a:extLst>
               <a:ext uri="{FF2B5EF4-FFF2-40B4-BE49-F238E27FC236}">
-                <a16:creationId xmlns:a16="http://schemas.microsoft.com/office/drawing/2014/main" id="{1EA535A0-7E36-7637-F9EB-567251341347}"/>
+                <a16:creationId xmlns:a16="http://schemas.microsoft.com/office/drawing/2014/main" id="{D560B954-F4D7-C245-342E-4719C58D76B2}"/>
               </a:ext>
             </a:extLst>
           </p:cNvPr>
@@ -8730,7 +8730,7 @@
           <p:cNvPr id="26" name="TextBox 25">
             <a:extLst>
               <a:ext uri="{FF2B5EF4-FFF2-40B4-BE49-F238E27FC236}">
-                <a16:creationId xmlns:a16="http://schemas.microsoft.com/office/drawing/2014/main" id="{4074438F-B52D-3C8E-D005-9D7BAA391FB7}"/>
+                <a16:creationId xmlns:a16="http://schemas.microsoft.com/office/drawing/2014/main" id="{A2CA4D83-97D1-0323-E818-73EE87266BE4}"/>
               </a:ext>
             </a:extLst>
           </p:cNvPr>
@@ -8770,7 +8770,7 @@
           <p:cNvPr id="27" name="Прямоугольник 26">
             <a:extLst>
               <a:ext uri="{FF2B5EF4-FFF2-40B4-BE49-F238E27FC236}">
-                <a16:creationId xmlns:a16="http://schemas.microsoft.com/office/drawing/2014/main" id="{739B5026-9151-F04F-B922-4DDEA34FF96B}"/>
+                <a16:creationId xmlns:a16="http://schemas.microsoft.com/office/drawing/2014/main" id="{33146872-3693-0BDC-3ADE-8B8832CAEE9B}"/>
               </a:ext>
             </a:extLst>
           </p:cNvPr>
@@ -8838,7 +8838,7 @@
           <p:cNvPr id="28" name="Прямоугольник 27">
             <a:extLst>
               <a:ext uri="{FF2B5EF4-FFF2-40B4-BE49-F238E27FC236}">
-                <a16:creationId xmlns:a16="http://schemas.microsoft.com/office/drawing/2014/main" id="{688B8011-4CDC-6535-16EF-46A8ACB63508}"/>
+                <a16:creationId xmlns:a16="http://schemas.microsoft.com/office/drawing/2014/main" id="{C6B173DC-A782-056D-1477-02EC8786F7FD}"/>
               </a:ext>
             </a:extLst>
           </p:cNvPr>
@@ -8906,7 +8906,7 @@
           <p:cNvPr id="29" name="TextBox 28">
             <a:extLst>
               <a:ext uri="{FF2B5EF4-FFF2-40B4-BE49-F238E27FC236}">
-                <a16:creationId xmlns:a16="http://schemas.microsoft.com/office/drawing/2014/main" id="{3A5C29D0-A1C0-D8D1-4FF6-CD99BF287516}"/>
+                <a16:creationId xmlns:a16="http://schemas.microsoft.com/office/drawing/2014/main" id="{65638315-31B0-39D3-3DE1-5A25B2D910D0}"/>
               </a:ext>
             </a:extLst>
           </p:cNvPr>
@@ -8952,7 +8952,7 @@
           <p:cNvPr id="30" name="TextBox 29">
             <a:extLst>
               <a:ext uri="{FF2B5EF4-FFF2-40B4-BE49-F238E27FC236}">
-                <a16:creationId xmlns:a16="http://schemas.microsoft.com/office/drawing/2014/main" id="{1D2D648E-43FC-75FF-1EDF-317EB0F860E8}"/>
+                <a16:creationId xmlns:a16="http://schemas.microsoft.com/office/drawing/2014/main" id="{EA0782F3-9B21-8A83-E058-EFE3B44BBB92}"/>
               </a:ext>
             </a:extLst>
           </p:cNvPr>
@@ -8992,7 +8992,7 @@
           <p:cNvPr id="31" name="TextBox 30">
             <a:extLst>
               <a:ext uri="{FF2B5EF4-FFF2-40B4-BE49-F238E27FC236}">
-                <a16:creationId xmlns:a16="http://schemas.microsoft.com/office/drawing/2014/main" id="{63945D4C-EB3C-3692-5215-82A6AF77A67E}"/>
+                <a16:creationId xmlns:a16="http://schemas.microsoft.com/office/drawing/2014/main" id="{D4A9CF8D-0B9E-EDB7-77E8-04BE8F6A069B}"/>
               </a:ext>
             </a:extLst>
           </p:cNvPr>
@@ -9030,7 +9030,7 @@
     </p:spTree>
     <p:extLst>
       <p:ext uri="{BB962C8B-B14F-4D97-AF65-F5344CB8AC3E}">
-        <p14:creationId xmlns:p14="http://schemas.microsoft.com/office/powerpoint/2010/main" val="1375157487"/>
+        <p14:creationId xmlns:p14="http://schemas.microsoft.com/office/powerpoint/2010/main" val="4195680498"/>
       </p:ext>
     </p:extLst>
   </p:cSld>
@@ -9062,7 +9062,7 @@
           <p:cNvPr id="2" name="Прямоугольник 1">
             <a:extLst>
               <a:ext uri="{FF2B5EF4-FFF2-40B4-BE49-F238E27FC236}">
-                <a16:creationId xmlns:a16="http://schemas.microsoft.com/office/drawing/2014/main" id="{34D2BBBF-7C21-09E5-AE88-EADFC1235CCC}"/>
+                <a16:creationId xmlns:a16="http://schemas.microsoft.com/office/drawing/2014/main" id="{E444FA2B-B923-8064-1B1A-CD74608EB8E1}"/>
               </a:ext>
             </a:extLst>
           </p:cNvPr>
@@ -9130,7 +9130,7 @@
           <p:cNvPr id="3" name="Прямоугольник 2">
             <a:extLst>
               <a:ext uri="{FF2B5EF4-FFF2-40B4-BE49-F238E27FC236}">
-                <a16:creationId xmlns:a16="http://schemas.microsoft.com/office/drawing/2014/main" id="{3A3608DB-8B0C-BC99-F59C-259075484BB2}"/>
+                <a16:creationId xmlns:a16="http://schemas.microsoft.com/office/drawing/2014/main" id="{4E7A3E1F-70D5-2BD1-AB0A-6065ED2510C1}"/>
               </a:ext>
             </a:extLst>
           </p:cNvPr>
@@ -9198,7 +9198,7 @@
           <p:cNvPr id="4" name="TextBox 3">
             <a:extLst>
               <a:ext uri="{FF2B5EF4-FFF2-40B4-BE49-F238E27FC236}">
-                <a16:creationId xmlns:a16="http://schemas.microsoft.com/office/drawing/2014/main" id="{D2AECA4E-FFFB-2E4F-9F08-7E1D819BFBB0}"/>
+                <a16:creationId xmlns:a16="http://schemas.microsoft.com/office/drawing/2014/main" id="{9B81033A-1AAC-3AF7-8F6B-C4605426117E}"/>
               </a:ext>
             </a:extLst>
           </p:cNvPr>
@@ -9238,7 +9238,7 @@
           <p:cNvPr id="5" name="TextBox 4">
             <a:extLst>
               <a:ext uri="{FF2B5EF4-FFF2-40B4-BE49-F238E27FC236}">
-                <a16:creationId xmlns:a16="http://schemas.microsoft.com/office/drawing/2014/main" id="{9B96FD80-60FC-7828-7A61-4EB02ADDCCE5}"/>
+                <a16:creationId xmlns:a16="http://schemas.microsoft.com/office/drawing/2014/main" id="{CD0645F0-4469-6D16-660A-7FFDCD570996}"/>
               </a:ext>
             </a:extLst>
           </p:cNvPr>
@@ -9279,7 +9279,7 @@
           <p:cNvPr id="6" name="Прямоугольник 5">
             <a:extLst>
               <a:ext uri="{FF2B5EF4-FFF2-40B4-BE49-F238E27FC236}">
-                <a16:creationId xmlns:a16="http://schemas.microsoft.com/office/drawing/2014/main" id="{9BBFC87A-1E9E-6F7F-F691-E981DAF2B58B}"/>
+                <a16:creationId xmlns:a16="http://schemas.microsoft.com/office/drawing/2014/main" id="{DD19820A-926D-01F2-35D2-8DF9D468A4F3}"/>
               </a:ext>
             </a:extLst>
           </p:cNvPr>
@@ -9344,53 +9344,118 @@
       </p:sp>
       <p:pic>
         <p:nvPicPr>
-          <p:cNvPr id="7" name="demo-app">
-            <a:hlinkClick r:id="" action="ppaction://media"/>
-            <a:extLst>
-              <a:ext uri="{FF2B5EF4-FFF2-40B4-BE49-F238E27FC236}">
-                <a16:creationId xmlns:a16="http://schemas.microsoft.com/office/drawing/2014/main" id="{BB219300-692C-F7E6-AB90-1C96158066A0}"/>
+          <p:cNvPr id="8" name="Рисунок 7">
+            <a:extLst>
+              <a:ext uri="{FF2B5EF4-FFF2-40B4-BE49-F238E27FC236}">
+                <a16:creationId xmlns:a16="http://schemas.microsoft.com/office/drawing/2014/main" id="{F69C1A4E-6AEF-5EB2-3E48-C522DD5A76C0}"/>
               </a:ext>
             </a:extLst>
           </p:cNvPr>
           <p:cNvPicPr>
-            <a:picLocks/>
+            <a:picLocks noChangeAspect="1"/>
           </p:cNvPicPr>
-          <p:nvPr>
-            <a:videoFile r:link="rId2"/>
-            <p:extLst>
-              <p:ext uri="{DAA4B4D4-6D71-4841-9C94-3DE7FCFB9230}">
-                <p14:media xmlns:p14="http://schemas.microsoft.com/office/powerpoint/2010/main" r:embed="rId1"/>
-              </p:ext>
-            </p:extLst>
-          </p:nvPr>
+          <p:nvPr/>
         </p:nvPicPr>
         <p:blipFill>
-          <a:blip r:embed="rId4"/>
+          <a:blip r:embed="rId2">
+            <a:extLst>
+              <a:ext uri="{28A0092B-C50C-407E-A947-70E740481C1C}">
+                <a14:useLocalDpi xmlns:a14="http://schemas.microsoft.com/office/drawing/2010/main" val="0"/>
+              </a:ext>
+            </a:extLst>
+          </a:blip>
           <a:stretch>
             <a:fillRect/>
           </a:stretch>
         </p:blipFill>
         <p:spPr>
           <a:xfrm>
-            <a:off x="558800" y="1676400"/>
-            <a:ext cx="7112000" cy="4000500"/>
-          </a:xfrm>
-          <a:prstGeom prst="rect">
-            <a:avLst/>
-          </a:prstGeom>
-          <a:ln w="19050">
-            <a:solidFill>
-              <a:srgbClr val="5B4B6E"/>
-            </a:solidFill>
-          </a:ln>
+            <a:off x="558800" y="1270000"/>
+            <a:ext cx="3175000" cy="2286000"/>
+          </a:xfrm>
+          <a:prstGeom prst="rect">
+            <a:avLst/>
+          </a:prstGeom>
         </p:spPr>
       </p:pic>
-      <p:sp>
-        <p:nvSpPr>
-          <p:cNvPr id="8" name="TextBox 7">
-            <a:extLst>
-              <a:ext uri="{FF2B5EF4-FFF2-40B4-BE49-F238E27FC236}">
-                <a16:creationId xmlns:a16="http://schemas.microsoft.com/office/drawing/2014/main" id="{96E13FBD-A884-6FED-0686-C7FB68FA0558}"/>
+      <p:pic>
+        <p:nvPicPr>
+          <p:cNvPr id="10" name="Рисунок 9">
+            <a:extLst>
+              <a:ext uri="{FF2B5EF4-FFF2-40B4-BE49-F238E27FC236}">
+                <a16:creationId xmlns:a16="http://schemas.microsoft.com/office/drawing/2014/main" id="{C9B5F76C-5ACF-A6BE-CA3C-3B6EC5D7493E}"/>
+              </a:ext>
+            </a:extLst>
+          </p:cNvPr>
+          <p:cNvPicPr>
+            <a:picLocks noChangeAspect="1"/>
+          </p:cNvPicPr>
+          <p:nvPr/>
+        </p:nvPicPr>
+        <p:blipFill>
+          <a:blip r:embed="rId3">
+            <a:extLst>
+              <a:ext uri="{28A0092B-C50C-407E-A947-70E740481C1C}">
+                <a14:useLocalDpi xmlns:a14="http://schemas.microsoft.com/office/drawing/2010/main" val="0"/>
+              </a:ext>
+            </a:extLst>
+          </a:blip>
+          <a:stretch>
+            <a:fillRect/>
+          </a:stretch>
+        </p:blipFill>
+        <p:spPr>
+          <a:xfrm>
+            <a:off x="3937000" y="1270000"/>
+            <a:ext cx="3175000" cy="2286000"/>
+          </a:xfrm>
+          <a:prstGeom prst="rect">
+            <a:avLst/>
+          </a:prstGeom>
+        </p:spPr>
+      </p:pic>
+      <p:pic>
+        <p:nvPicPr>
+          <p:cNvPr id="12" name="Рисунок 11">
+            <a:extLst>
+              <a:ext uri="{FF2B5EF4-FFF2-40B4-BE49-F238E27FC236}">
+                <a16:creationId xmlns:a16="http://schemas.microsoft.com/office/drawing/2014/main" id="{6C5989A7-06D9-1F9E-6024-7CB9739DE64C}"/>
+              </a:ext>
+            </a:extLst>
+          </p:cNvPr>
+          <p:cNvPicPr>
+            <a:picLocks noChangeAspect="1"/>
+          </p:cNvPicPr>
+          <p:nvPr/>
+        </p:nvPicPr>
+        <p:blipFill>
+          <a:blip r:embed="rId4">
+            <a:extLst>
+              <a:ext uri="{28A0092B-C50C-407E-A947-70E740481C1C}">
+                <a14:useLocalDpi xmlns:a14="http://schemas.microsoft.com/office/drawing/2010/main" val="0"/>
+              </a:ext>
+            </a:extLst>
+          </a:blip>
+          <a:stretch>
+            <a:fillRect/>
+          </a:stretch>
+        </p:blipFill>
+        <p:spPr>
+          <a:xfrm>
+            <a:off x="7315200" y="1270000"/>
+            <a:ext cx="3175000" cy="2286000"/>
+          </a:xfrm>
+          <a:prstGeom prst="rect">
+            <a:avLst/>
+          </a:prstGeom>
+        </p:spPr>
+      </p:pic>
+      <p:sp>
+        <p:nvSpPr>
+          <p:cNvPr id="13" name="TextBox 12">
+            <a:extLst>
+              <a:ext uri="{FF2B5EF4-FFF2-40B4-BE49-F238E27FC236}">
+                <a16:creationId xmlns:a16="http://schemas.microsoft.com/office/drawing/2014/main" id="{DBD38C23-83AB-3B4C-1F1D-35C523D12AE1}"/>
               </a:ext>
             </a:extLst>
           </p:cNvPr>
@@ -9399,48 +9464,8 @@
         </p:nvSpPr>
         <p:spPr>
           <a:xfrm>
-            <a:off x="558800" y="5816600"/>
-            <a:ext cx="7112000" cy="369332"/>
-          </a:xfrm>
-          <a:prstGeom prst="rect">
-            <a:avLst/>
-          </a:prstGeom>
-          <a:noFill/>
-        </p:spPr>
-        <p:txBody>
-          <a:bodyPr vert="horz" wrap="square" lIns="0" tIns="0" rIns="0" bIns="0" rtlCol="0">
-            <a:noAutofit/>
-          </a:bodyPr>
-          <a:lstStyle/>
-          <a:p>
-            <a:r>
-              <a:rPr lang="ru-RU" sz="1400">
-                <a:solidFill>
-                  <a:srgbClr val="6B6472"/>
-                </a:solidFill>
-                <a:latin typeface="Times New Roman" panose="02020603050405020304" pitchFamily="18" charset="0"/>
-              </a:rPr>
-              <a:t>Демонстрация занимает около 25 секунд</a:t>
-            </a:r>
-          </a:p>
-        </p:txBody>
-      </p:sp>
-      <p:sp>
-        <p:nvSpPr>
-          <p:cNvPr id="9" name="TextBox 8">
-            <a:extLst>
-              <a:ext uri="{FF2B5EF4-FFF2-40B4-BE49-F238E27FC236}">
-                <a16:creationId xmlns:a16="http://schemas.microsoft.com/office/drawing/2014/main" id="{A5D42C6B-7ED8-3272-3F6D-3125B3603938}"/>
-              </a:ext>
-            </a:extLst>
-          </p:cNvPr>
-          <p:cNvSpPr txBox="1"/>
-          <p:nvPr/>
-        </p:nvSpPr>
-        <p:spPr>
-          <a:xfrm>
-            <a:off x="8001000" y="1727200"/>
-            <a:ext cx="3632200" cy="369332"/>
+            <a:off x="558800" y="4064000"/>
+            <a:ext cx="11074400" cy="369332"/>
           </a:xfrm>
           <a:prstGeom prst="rect">
             <a:avLst/>
@@ -9462,7 +9487,7 @@
               <a:buChar char="•"/>
             </a:pPr>
             <a:r>
-              <a:rPr lang="ru-RU" sz="1500">
+              <a:rPr lang="ru-RU" sz="1600">
                 <a:solidFill>
                   <a:srgbClr val="2B2233"/>
                 </a:solidFill>
@@ -9481,7 +9506,7 @@
               <a:buChar char="•"/>
             </a:pPr>
             <a:r>
-              <a:rPr lang="ru-RU" sz="1500">
+              <a:rPr lang="ru-RU" sz="1600">
                 <a:solidFill>
                   <a:srgbClr val="2B2233"/>
                 </a:solidFill>
@@ -9500,13 +9525,13 @@
               <a:buChar char="•"/>
             </a:pPr>
             <a:r>
-              <a:rPr lang="ru-RU" sz="1500">
+              <a:rPr lang="ru-RU" sz="1600">
                 <a:solidFill>
                   <a:srgbClr val="2B2233"/>
                 </a:solidFill>
                 <a:latin typeface="Times New Roman" panose="02020603050405020304" pitchFamily="18" charset="0"/>
               </a:rPr>
-              <a:t>Проверка работы учителем, выставление балла и комментария</a:t>
+              <a:t>Проверка работы учителем, выставление балла и комментария, формирование ведомости</a:t>
             </a:r>
           </a:p>
           <a:p>
@@ -9519,26 +9544,7 @@
               <a:buChar char="•"/>
             </a:pPr>
             <a:r>
-              <a:rPr lang="ru-RU" sz="1500">
-                <a:solidFill>
-                  <a:srgbClr val="2B2233"/>
-                </a:solidFill>
-                <a:latin typeface="Times New Roman" panose="02020603050405020304" pitchFamily="18" charset="0"/>
-              </a:rPr>
-              <a:t>Формирование ведомости успеваемости по курсу</a:t>
-            </a:r>
-          </a:p>
-          <a:p>
-            <a:pPr indent="330200">
-              <a:spcAft>
-                <a:spcPts val="1000"/>
-              </a:spcAft>
-              <a:buSzPct val="90000"/>
-              <a:buFont typeface="+mj-lt"/>
-              <a:buChar char="•"/>
-            </a:pPr>
-            <a:r>
-              <a:rPr lang="ru-RU" sz="1500">
+              <a:rPr lang="ru-RU" sz="1600">
                 <a:solidFill>
                   <a:srgbClr val="2B2233"/>
                 </a:solidFill>
@@ -9556,7 +9562,7 @@
               <a:buFont typeface="+mj-lt"/>
               <a:buChar char="•"/>
             </a:pPr>
-            <a:endParaRPr lang="ru-RU" sz="1500">
+            <a:endParaRPr lang="ru-RU" sz="1600">
               <a:solidFill>
                 <a:srgbClr val="2B2233"/>
               </a:solidFill>
@@ -9568,148 +9574,13 @@
     </p:spTree>
     <p:extLst>
       <p:ext uri="{BB962C8B-B14F-4D97-AF65-F5344CB8AC3E}">
-        <p14:creationId xmlns:p14="http://schemas.microsoft.com/office/powerpoint/2010/main" val="2275575573"/>
+        <p14:creationId xmlns:p14="http://schemas.microsoft.com/office/powerpoint/2010/main" val="4147453297"/>
       </p:ext>
     </p:extLst>
   </p:cSld>
   <p:clrMapOvr>
     <a:masterClrMapping/>
   </p:clrMapOvr>
-  <p:timing>
-    <p:tnLst>
-      <p:par>
-        <p:cTn id="1" dur="indefinite" restart="never" nodeType="tmRoot">
-          <p:childTnLst>
-            <p:seq concurrent="1" nextAc="seek">
-              <p:cTn id="2" dur="indefinite" nodeType="mainSeq">
-                <p:childTnLst>
-                  <p:par>
-                    <p:cTn id="3" fill="hold">
-                      <p:stCondLst>
-                        <p:cond delay="indefinite"/>
-                      </p:stCondLst>
-                      <p:childTnLst>
-                        <p:par>
-                          <p:cTn id="4" fill="hold">
-                            <p:stCondLst>
-                              <p:cond delay="0"/>
-                            </p:stCondLst>
-                            <p:childTnLst>
-                              <p:par>
-                                <p:cTn id="5" presetID="1" presetClass="mediacall" presetSubtype="0" fill="hold" nodeType="clickEffect">
-                                  <p:stCondLst>
-                                    <p:cond delay="0"/>
-                                  </p:stCondLst>
-                                  <p:childTnLst>
-                                    <p:cmd type="call" cmd="playFrom(0.0)">
-                                      <p:cBhvr>
-                                        <p:cTn id="6" dur="24123" fill="hold"/>
-                                        <p:tgtEl>
-                                          <p:spTgt spid="7"/>
-                                        </p:tgtEl>
-                                      </p:cBhvr>
-                                    </p:cmd>
-                                  </p:childTnLst>
-                                </p:cTn>
-                              </p:par>
-                            </p:childTnLst>
-                          </p:cTn>
-                        </p:par>
-                      </p:childTnLst>
-                    </p:cTn>
-                  </p:par>
-                </p:childTnLst>
-              </p:cTn>
-              <p:prevCondLst>
-                <p:cond evt="onPrev" delay="0">
-                  <p:tgtEl>
-                    <p:sldTgt/>
-                  </p:tgtEl>
-                </p:cond>
-              </p:prevCondLst>
-              <p:nextCondLst>
-                <p:cond evt="onNext" delay="0">
-                  <p:tgtEl>
-                    <p:sldTgt/>
-                  </p:tgtEl>
-                </p:cond>
-              </p:nextCondLst>
-            </p:seq>
-            <p:video>
-              <p:cMediaNode vol="80000" showWhenStopped="0">
-                <p:cTn id="7" fill="hold" display="0">
-                  <p:stCondLst>
-                    <p:cond delay="indefinite"/>
-                  </p:stCondLst>
-                </p:cTn>
-                <p:tgtEl>
-                  <p:spTgt spid="7"/>
-                </p:tgtEl>
-              </p:cMediaNode>
-            </p:video>
-            <p:seq concurrent="1" nextAc="seek">
-              <p:cTn id="8" restart="whenNotActive" fill="hold" evtFilter="cancelBubble" nodeType="interactiveSeq">
-                <p:stCondLst>
-                  <p:cond evt="onClick" delay="0">
-                    <p:tgtEl>
-                      <p:spTgt spid="7"/>
-                    </p:tgtEl>
-                  </p:cond>
-                </p:stCondLst>
-                <p:endSync evt="end" delay="0">
-                  <p:rtn val="all"/>
-                </p:endSync>
-                <p:childTnLst>
-                  <p:par>
-                    <p:cTn id="9" fill="hold">
-                      <p:stCondLst>
-                        <p:cond delay="0"/>
-                      </p:stCondLst>
-                      <p:childTnLst>
-                        <p:par>
-                          <p:cTn id="10" fill="hold">
-                            <p:stCondLst>
-                              <p:cond delay="0"/>
-                            </p:stCondLst>
-                            <p:childTnLst>
-                              <p:par>
-                                <p:cTn id="11" presetID="2" presetClass="mediacall" presetSubtype="0" fill="hold" nodeType="clickEffect">
-                                  <p:stCondLst>
-                                    <p:cond delay="0"/>
-                                  </p:stCondLst>
-                                  <p:childTnLst>
-                                    <p:cmd type="call" cmd="togglePause">
-                                      <p:cBhvr>
-                                        <p:cTn id="12" dur="1" fill="hold"/>
-                                        <p:tgtEl>
-                                          <p:spTgt spid="7"/>
-                                        </p:tgtEl>
-                                      </p:cBhvr>
-                                    </p:cmd>
-                                  </p:childTnLst>
-                                </p:cTn>
-                              </p:par>
-                            </p:childTnLst>
-                          </p:cTn>
-                        </p:par>
-                      </p:childTnLst>
-                    </p:cTn>
-                  </p:par>
-                </p:childTnLst>
-              </p:cTn>
-              <p:nextCondLst>
-                <p:cond evt="onClick" delay="0">
-                  <p:tgtEl>
-                    <p:spTgt spid="7"/>
-                  </p:tgtEl>
-                </p:cond>
-              </p:nextCondLst>
-            </p:seq>
-          </p:childTnLst>
-        </p:cTn>
-      </p:par>
-    </p:tnLst>
-  </p:timing>
 </p:sld>
 </file>
 
@@ -9735,7 +9606,7 @@
           <p:cNvPr id="2" name="Прямоугольник 1">
             <a:extLst>
               <a:ext uri="{FF2B5EF4-FFF2-40B4-BE49-F238E27FC236}">
-                <a16:creationId xmlns:a16="http://schemas.microsoft.com/office/drawing/2014/main" id="{70E3157C-E616-279C-6C6E-C90100D7E6C4}"/>
+                <a16:creationId xmlns:a16="http://schemas.microsoft.com/office/drawing/2014/main" id="{F6BE5FB4-E801-F8EA-2CE6-03D6E6DC1DCD}"/>
               </a:ext>
             </a:extLst>
           </p:cNvPr>
@@ -9803,7 +9674,7 @@
           <p:cNvPr id="3" name="Прямоугольник 2">
             <a:extLst>
               <a:ext uri="{FF2B5EF4-FFF2-40B4-BE49-F238E27FC236}">
-                <a16:creationId xmlns:a16="http://schemas.microsoft.com/office/drawing/2014/main" id="{5A23E356-8D12-B77C-5B44-2420EDB7516A}"/>
+                <a16:creationId xmlns:a16="http://schemas.microsoft.com/office/drawing/2014/main" id="{86122630-2942-DA12-28E7-386A8AB41FC5}"/>
               </a:ext>
             </a:extLst>
           </p:cNvPr>
@@ -9871,7 +9742,7 @@
           <p:cNvPr id="4" name="TextBox 3">
             <a:extLst>
               <a:ext uri="{FF2B5EF4-FFF2-40B4-BE49-F238E27FC236}">
-                <a16:creationId xmlns:a16="http://schemas.microsoft.com/office/drawing/2014/main" id="{6063E125-E878-DCB5-35BC-E6528E879E72}"/>
+                <a16:creationId xmlns:a16="http://schemas.microsoft.com/office/drawing/2014/main" id="{C8113A6B-8B3E-25E0-FFC3-11E68DC33053}"/>
               </a:ext>
             </a:extLst>
           </p:cNvPr>
@@ -9911,7 +9782,7 @@
           <p:cNvPr id="5" name="Прямоугольник 4">
             <a:extLst>
               <a:ext uri="{FF2B5EF4-FFF2-40B4-BE49-F238E27FC236}">
-                <a16:creationId xmlns:a16="http://schemas.microsoft.com/office/drawing/2014/main" id="{DF344452-8E85-EF86-CB81-90A8FD3B9588}"/>
+                <a16:creationId xmlns:a16="http://schemas.microsoft.com/office/drawing/2014/main" id="{6B35A9E2-DF2E-97B9-DEC4-7ABF7DB14274}"/>
               </a:ext>
             </a:extLst>
           </p:cNvPr>
@@ -9979,7 +9850,7 @@
           <p:cNvPr id="6" name="TextBox 5">
             <a:extLst>
               <a:ext uri="{FF2B5EF4-FFF2-40B4-BE49-F238E27FC236}">
-                <a16:creationId xmlns:a16="http://schemas.microsoft.com/office/drawing/2014/main" id="{1E309CC6-AD46-6A3E-2326-551A06F812CA}"/>
+                <a16:creationId xmlns:a16="http://schemas.microsoft.com/office/drawing/2014/main" id="{826E5247-6872-9B27-1158-C2C44D905039}"/>
               </a:ext>
             </a:extLst>
           </p:cNvPr>
@@ -10019,7 +9890,7 @@
           <p:cNvPr id="7" name="TextBox 6">
             <a:extLst>
               <a:ext uri="{FF2B5EF4-FFF2-40B4-BE49-F238E27FC236}">
-                <a16:creationId xmlns:a16="http://schemas.microsoft.com/office/drawing/2014/main" id="{7F8E11E5-DC70-19C8-4426-C43598264144}"/>
+                <a16:creationId xmlns:a16="http://schemas.microsoft.com/office/drawing/2014/main" id="{555D625B-9006-DF91-5ECD-1C85E933325E}"/>
               </a:ext>
             </a:extLst>
           </p:cNvPr>
@@ -10059,7 +9930,7 @@
           <p:cNvPr id="8" name="TextBox 7">
             <a:extLst>
               <a:ext uri="{FF2B5EF4-FFF2-40B4-BE49-F238E27FC236}">
-                <a16:creationId xmlns:a16="http://schemas.microsoft.com/office/drawing/2014/main" id="{D60C12A0-F4ED-49FE-95E3-22916E2B947F}"/>
+                <a16:creationId xmlns:a16="http://schemas.microsoft.com/office/drawing/2014/main" id="{CD692202-B522-978A-1C6C-8FB42EC87FB5}"/>
               </a:ext>
             </a:extLst>
           </p:cNvPr>
@@ -10099,7 +9970,7 @@
           <p:cNvPr id="9" name="TextBox 8">
             <a:extLst>
               <a:ext uri="{FF2B5EF4-FFF2-40B4-BE49-F238E27FC236}">
-                <a16:creationId xmlns:a16="http://schemas.microsoft.com/office/drawing/2014/main" id="{5EAB745E-698C-D7AB-6732-FE955EE56EB4}"/>
+                <a16:creationId xmlns:a16="http://schemas.microsoft.com/office/drawing/2014/main" id="{5C9D8D12-BE7E-9CA4-4702-DF2B8B6A7BDB}"/>
               </a:ext>
             </a:extLst>
           </p:cNvPr>
@@ -10137,7 +10008,7 @@
     </p:spTree>
     <p:extLst>
       <p:ext uri="{BB962C8B-B14F-4D97-AF65-F5344CB8AC3E}">
-        <p14:creationId xmlns:p14="http://schemas.microsoft.com/office/powerpoint/2010/main" val="4222057683"/>
+        <p14:creationId xmlns:p14="http://schemas.microsoft.com/office/powerpoint/2010/main" val="1795533461"/>
       </p:ext>
     </p:extLst>
   </p:cSld>

</xml_diff>